<commit_message>
feat: Add live tool output and dashboard findings slides to PPTX
</commit_message>
<xml_diff>
--- a/Konsolidasi_Analyzer_Solution_Architecture.pptx
+++ b/Konsolidasi_Analyzer_Solution_Architecture.pptx
@@ -15,6 +15,7 @@
     <p:sldId id="263" r:id="rId14"/>
     <p:sldId id="264" r:id="rId15"/>
     <p:sldId id="265" r:id="rId16"/>
+    <p:sldId id="266" r:id="rId17"/>
   </p:sldIdLst>
   <p:sldSz cx="12191695" cy="6858000" type="screen4x3"/>
   <p:notesSz cx="6858000" cy="9144000"/>
@@ -3213,7 +3214,7 @@
               </a:defRPr>
             </a:pPr>
             <a:r>
-              <a:t>ENTERPRISE SOLUTION ARCHITECTURE &amp; STAKEHOLDER ALIGNMENT</a:t>
+              <a:t>ENTERPRISE SOLUTION ARCHITECTURE &amp; PRESENTATION OUTPUT</a:t>
             </a:r>
           </a:p>
           <a:p>
@@ -3258,7 +3259,7 @@
               </a:defRPr>
             </a:pPr>
             <a:r>
-              <a:t>An automated system for group financial consolidation review, mathematical anomaly detection (IFRS 10 / PSAK 65 NCI &amp; IAS 24 / PSAK 7 Related-Parties), and internal audit sign-off workflows.</a:t>
+              <a:t>Executive presentation deck showcasing the architectural blueprint, live tool outputs, quantitative anomaly flags, and auditor sign-off workflows for Holding Foundation &amp; 5 Subsidiaries.</a:t>
             </a:r>
           </a:p>
         </p:txBody>
@@ -3338,7 +3339,7 @@
               </a:defRPr>
             </a:pPr>
             <a:r>
-              <a:t>Target Structure: Holding Foundation (Induk) &amp; 5 Operating Subsidiaries (Subsidiaries I – V)</a:t>
+              <a:t>Entities: Holding Foundation (Induk) &amp; 5 Operating Subsidiaries (PT Anak I – V)</a:t>
             </a:r>
           </a:p>
           <a:p>
@@ -3353,7 +3354,7 @@
               </a:defRPr>
             </a:pPr>
             <a:r>
-              <a:t>Standards: IFRS 10 / PSAK 65 (NCI Attribution) &amp;bull; IAS 24 / PSAK 7 (Related-Party Transactions) &amp;bull; POJK Prudential Ratios</a:t>
+              <a:t>Standards: IFRS 10 / PSAK 65 (NCI Attribution) &amp;bull; IAS 24 / PSAK 7 (Related-Parties) &amp;bull; POJK Prudential Ratios</a:t>
             </a:r>
           </a:p>
         </p:txBody>
@@ -3492,6 +3493,750 @@
               </a:defRPr>
             </a:pPr>
             <a:r>
+              <a:t>DEPLOYMENT PLAN</a:t>
+            </a:r>
+          </a:p>
+        </p:txBody>
+      </p:sp>
+      <p:sp>
+        <p:nvSpPr>
+          <p:cNvPr id="5" name="TextBox 4"/>
+          <p:cNvSpPr txBox="1"/>
+          <p:nvPr/>
+        </p:nvSpPr>
+        <p:spPr>
+          <a:xfrm>
+            <a:off x="731520" y="777240"/>
+            <a:ext cx="10728655" cy="640080"/>
+          </a:xfrm>
+          <a:prstGeom prst="rect">
+            <a:avLst/>
+          </a:prstGeom>
+          <a:noFill/>
+        </p:spPr>
+        <p:txBody>
+          <a:bodyPr wrap="square">
+            <a:spAutoFit/>
+          </a:bodyPr>
+          <a:lstStyle/>
+          <a:p>
+            <a:pPr>
+              <a:defRPr sz="2200" b="1">
+                <a:solidFill>
+                  <a:srgbClr val="0F172A"/>
+                </a:solidFill>
+              </a:defRPr>
+            </a:pPr>
+            <a:r>
+              <a:t>Phased Enterprise Implementation Roadmap</a:t>
+            </a:r>
+          </a:p>
+        </p:txBody>
+      </p:sp>
+      <p:sp>
+        <p:nvSpPr>
+          <p:cNvPr id="6" name="Rounded Rectangle 5"/>
+          <p:cNvSpPr/>
+          <p:nvPr/>
+        </p:nvSpPr>
+        <p:spPr>
+          <a:xfrm>
+            <a:off x="731520" y="1600200"/>
+            <a:ext cx="3328416" cy="4389120"/>
+          </a:xfrm>
+          <a:prstGeom prst="roundRect">
+            <a:avLst/>
+          </a:prstGeom>
+          <a:solidFill>
+            <a:srgbClr val="F8FAFC"/>
+          </a:solidFill>
+          <a:ln w="12700">
+            <a:solidFill>
+              <a:srgbClr val="E2E8F0"/>
+            </a:solidFill>
+          </a:ln>
+        </p:spPr>
+        <p:style>
+          <a:lnRef idx="1">
+            <a:schemeClr val="accent1"/>
+          </a:lnRef>
+          <a:fillRef idx="3">
+            <a:schemeClr val="accent1"/>
+          </a:fillRef>
+          <a:effectRef idx="2">
+            <a:schemeClr val="accent1"/>
+          </a:effectRef>
+          <a:fontRef idx="minor">
+            <a:schemeClr val="lt1"/>
+          </a:fontRef>
+        </p:style>
+        <p:txBody>
+          <a:bodyPr rtlCol="0" anchor="ctr"/>
+          <a:lstStyle/>
+          <a:p>
+            <a:pPr algn="ctr"/>
+          </a:p>
+        </p:txBody>
+      </p:sp>
+      <p:sp>
+        <p:nvSpPr>
+          <p:cNvPr id="7" name="Rounded Rectangle 6"/>
+          <p:cNvSpPr/>
+          <p:nvPr/>
+        </p:nvSpPr>
+        <p:spPr>
+          <a:xfrm>
+            <a:off x="731520" y="1600200"/>
+            <a:ext cx="3328416" cy="73152"/>
+          </a:xfrm>
+          <a:prstGeom prst="roundRect">
+            <a:avLst/>
+          </a:prstGeom>
+          <a:solidFill>
+            <a:srgbClr val="0D9488"/>
+          </a:solidFill>
+          <a:ln>
+            <a:noFill/>
+          </a:ln>
+        </p:spPr>
+        <p:style>
+          <a:lnRef idx="1">
+            <a:schemeClr val="accent1"/>
+          </a:lnRef>
+          <a:fillRef idx="3">
+            <a:schemeClr val="accent1"/>
+          </a:fillRef>
+          <a:effectRef idx="2">
+            <a:schemeClr val="accent1"/>
+          </a:effectRef>
+          <a:fontRef idx="minor">
+            <a:schemeClr val="lt1"/>
+          </a:fontRef>
+        </p:style>
+        <p:txBody>
+          <a:bodyPr rtlCol="0" anchor="ctr"/>
+          <a:lstStyle/>
+          <a:p>
+            <a:pPr algn="ctr"/>
+          </a:p>
+        </p:txBody>
+      </p:sp>
+      <p:sp>
+        <p:nvSpPr>
+          <p:cNvPr id="8" name="TextBox 7"/>
+          <p:cNvSpPr txBox="1"/>
+          <p:nvPr/>
+        </p:nvSpPr>
+        <p:spPr>
+          <a:xfrm>
+            <a:off x="950976" y="1819656"/>
+            <a:ext cx="2889504" cy="3950208"/>
+          </a:xfrm>
+          <a:prstGeom prst="rect">
+            <a:avLst/>
+          </a:prstGeom>
+          <a:noFill/>
+        </p:spPr>
+        <p:txBody>
+          <a:bodyPr wrap="square">
+            <a:spAutoFit/>
+          </a:bodyPr>
+          <a:lstStyle/>
+          <a:p>
+            <a:pPr>
+              <a:spcAft>
+                <a:spcPts val="800"/>
+              </a:spcAft>
+              <a:defRPr sz="1350" b="1">
+                <a:solidFill>
+                  <a:srgbClr val="0D9488"/>
+                </a:solidFill>
+              </a:defRPr>
+            </a:pPr>
+            <a:r>
+              <a:t>Phase 1: Working PoC (Delivered)</a:t>
+            </a:r>
+            <a:br/>
+            <a:r>
+              <a:t>(Month 1)</a:t>
+            </a:r>
+          </a:p>
+          <a:p>
+            <a:pPr>
+              <a:spcAft>
+                <a:spcPts val="400"/>
+              </a:spcAft>
+              <a:defRPr sz="1100">
+                <a:solidFill>
+                  <a:srgbClr val="1E293B"/>
+                </a:solidFill>
+              </a:defRPr>
+            </a:pPr>
+            <a:r>
+              <a:t>• Consolidation rule engine validated for 6 entities.</a:t>
+            </a:r>
+          </a:p>
+          <a:p>
+            <a:pPr>
+              <a:spcAft>
+                <a:spcPts val="400"/>
+              </a:spcAft>
+              <a:defRPr sz="1100">
+                <a:solidFill>
+                  <a:srgbClr val="1E293B"/>
+                </a:solidFill>
+              </a:defRPr>
+            </a:pPr>
+            <a:r>
+              <a:t>• Conversational AI Copilot with quick-action chips.</a:t>
+            </a:r>
+          </a:p>
+          <a:p>
+            <a:pPr>
+              <a:spcAft>
+                <a:spcPts val="400"/>
+              </a:spcAft>
+              <a:defRPr sz="1100">
+                <a:solidFill>
+                  <a:srgbClr val="1E293B"/>
+                </a:solidFill>
+              </a:defRPr>
+            </a:pPr>
+            <a:r>
+              <a:t>• Actionable 'Review Workspace' for anomaly tracking.</a:t>
+            </a:r>
+          </a:p>
+          <a:p>
+            <a:pPr>
+              <a:spcAft>
+                <a:spcPts val="400"/>
+              </a:spcAft>
+              <a:defRPr sz="1100">
+                <a:solidFill>
+                  <a:srgbClr val="1E293B"/>
+                </a:solidFill>
+              </a:defRPr>
+            </a:pPr>
+            <a:r>
+              <a:t>• Self-contained local execution &amp; GitHub repository.</a:t>
+            </a:r>
+          </a:p>
+        </p:txBody>
+      </p:sp>
+      <p:sp>
+        <p:nvSpPr>
+          <p:cNvPr id="9" name="Rounded Rectangle 8"/>
+          <p:cNvSpPr/>
+          <p:nvPr/>
+        </p:nvSpPr>
+        <p:spPr>
+          <a:xfrm>
+            <a:off x="4416552" y="1600200"/>
+            <a:ext cx="3328416" cy="4389120"/>
+          </a:xfrm>
+          <a:prstGeom prst="roundRect">
+            <a:avLst/>
+          </a:prstGeom>
+          <a:solidFill>
+            <a:srgbClr val="F8FAFC"/>
+          </a:solidFill>
+          <a:ln w="12700">
+            <a:solidFill>
+              <a:srgbClr val="E2E8F0"/>
+            </a:solidFill>
+          </a:ln>
+        </p:spPr>
+        <p:style>
+          <a:lnRef idx="1">
+            <a:schemeClr val="accent1"/>
+          </a:lnRef>
+          <a:fillRef idx="3">
+            <a:schemeClr val="accent1"/>
+          </a:fillRef>
+          <a:effectRef idx="2">
+            <a:schemeClr val="accent1"/>
+          </a:effectRef>
+          <a:fontRef idx="minor">
+            <a:schemeClr val="lt1"/>
+          </a:fontRef>
+        </p:style>
+        <p:txBody>
+          <a:bodyPr rtlCol="0" anchor="ctr"/>
+          <a:lstStyle/>
+          <a:p>
+            <a:pPr algn="ctr"/>
+          </a:p>
+        </p:txBody>
+      </p:sp>
+      <p:sp>
+        <p:nvSpPr>
+          <p:cNvPr id="10" name="Rounded Rectangle 9"/>
+          <p:cNvSpPr/>
+          <p:nvPr/>
+        </p:nvSpPr>
+        <p:spPr>
+          <a:xfrm>
+            <a:off x="4416552" y="1600200"/>
+            <a:ext cx="3328416" cy="73152"/>
+          </a:xfrm>
+          <a:prstGeom prst="roundRect">
+            <a:avLst/>
+          </a:prstGeom>
+          <a:solidFill>
+            <a:srgbClr val="B48214"/>
+          </a:solidFill>
+          <a:ln>
+            <a:noFill/>
+          </a:ln>
+        </p:spPr>
+        <p:style>
+          <a:lnRef idx="1">
+            <a:schemeClr val="accent1"/>
+          </a:lnRef>
+          <a:fillRef idx="3">
+            <a:schemeClr val="accent1"/>
+          </a:fillRef>
+          <a:effectRef idx="2">
+            <a:schemeClr val="accent1"/>
+          </a:effectRef>
+          <a:fontRef idx="minor">
+            <a:schemeClr val="lt1"/>
+          </a:fontRef>
+        </p:style>
+        <p:txBody>
+          <a:bodyPr rtlCol="0" anchor="ctr"/>
+          <a:lstStyle/>
+          <a:p>
+            <a:pPr algn="ctr"/>
+          </a:p>
+        </p:txBody>
+      </p:sp>
+      <p:sp>
+        <p:nvSpPr>
+          <p:cNvPr id="11" name="TextBox 10"/>
+          <p:cNvSpPr txBox="1"/>
+          <p:nvPr/>
+        </p:nvSpPr>
+        <p:spPr>
+          <a:xfrm>
+            <a:off x="4636008" y="1819656"/>
+            <a:ext cx="2889504" cy="3950208"/>
+          </a:xfrm>
+          <a:prstGeom prst="rect">
+            <a:avLst/>
+          </a:prstGeom>
+          <a:noFill/>
+        </p:spPr>
+        <p:txBody>
+          <a:bodyPr wrap="square">
+            <a:spAutoFit/>
+          </a:bodyPr>
+          <a:lstStyle/>
+          <a:p>
+            <a:pPr>
+              <a:spcAft>
+                <a:spcPts val="800"/>
+              </a:spcAft>
+              <a:defRPr sz="1350" b="1">
+                <a:solidFill>
+                  <a:srgbClr val="B48214"/>
+                </a:solidFill>
+              </a:defRPr>
+            </a:pPr>
+            <a:r>
+              <a:t>Phase 2: Integration &amp; Pilot</a:t>
+            </a:r>
+            <a:br/>
+            <a:r>
+              <a:t>(Months 2 - 3)</a:t>
+            </a:r>
+          </a:p>
+          <a:p>
+            <a:pPr>
+              <a:spcAft>
+                <a:spcPts val="400"/>
+              </a:spcAft>
+              <a:defRPr sz="1100">
+                <a:solidFill>
+                  <a:srgbClr val="1E293B"/>
+                </a:solidFill>
+              </a:defRPr>
+            </a:pPr>
+            <a:r>
+              <a:t>• Direct ERP/GL database connectors (SAP/Oracle).</a:t>
+            </a:r>
+          </a:p>
+          <a:p>
+            <a:pPr>
+              <a:spcAft>
+                <a:spcPts val="400"/>
+              </a:spcAft>
+              <a:defRPr sz="1100">
+                <a:solidFill>
+                  <a:srgbClr val="1E293B"/>
+                </a:solidFill>
+              </a:defRPr>
+            </a:pPr>
+            <a:r>
+              <a:t>• Immutable point-in-time snapshot database store.</a:t>
+            </a:r>
+          </a:p>
+          <a:p>
+            <a:pPr>
+              <a:spcAft>
+                <a:spcPts val="400"/>
+              </a:spcAft>
+              <a:defRPr sz="1100">
+                <a:solidFill>
+                  <a:srgbClr val="1E293B"/>
+                </a:solidFill>
+              </a:defRPr>
+            </a:pPr>
+            <a:r>
+              <a:t>• Automated email/chat notification dispatch to subsidiaries.</a:t>
+            </a:r>
+          </a:p>
+          <a:p>
+            <a:pPr>
+              <a:spcAft>
+                <a:spcPts val="400"/>
+              </a:spcAft>
+              <a:defRPr sz="1100">
+                <a:solidFill>
+                  <a:srgbClr val="1E293B"/>
+                </a:solidFill>
+              </a:defRPr>
+            </a:pPr>
+            <a:r>
+              <a:t>• Parallel dry-run benchmarked against prior-year audited data.</a:t>
+            </a:r>
+          </a:p>
+        </p:txBody>
+      </p:sp>
+      <p:sp>
+        <p:nvSpPr>
+          <p:cNvPr id="12" name="Rounded Rectangle 11"/>
+          <p:cNvSpPr/>
+          <p:nvPr/>
+        </p:nvSpPr>
+        <p:spPr>
+          <a:xfrm>
+            <a:off x="8101584" y="1600200"/>
+            <a:ext cx="3328416" cy="4389120"/>
+          </a:xfrm>
+          <a:prstGeom prst="roundRect">
+            <a:avLst/>
+          </a:prstGeom>
+          <a:solidFill>
+            <a:srgbClr val="F8FAFC"/>
+          </a:solidFill>
+          <a:ln w="12700">
+            <a:solidFill>
+              <a:srgbClr val="E2E8F0"/>
+            </a:solidFill>
+          </a:ln>
+        </p:spPr>
+        <p:style>
+          <a:lnRef idx="1">
+            <a:schemeClr val="accent1"/>
+          </a:lnRef>
+          <a:fillRef idx="3">
+            <a:schemeClr val="accent1"/>
+          </a:fillRef>
+          <a:effectRef idx="2">
+            <a:schemeClr val="accent1"/>
+          </a:effectRef>
+          <a:fontRef idx="minor">
+            <a:schemeClr val="lt1"/>
+          </a:fontRef>
+        </p:style>
+        <p:txBody>
+          <a:bodyPr rtlCol="0" anchor="ctr"/>
+          <a:lstStyle/>
+          <a:p>
+            <a:pPr algn="ctr"/>
+          </a:p>
+        </p:txBody>
+      </p:sp>
+      <p:sp>
+        <p:nvSpPr>
+          <p:cNvPr id="13" name="Rounded Rectangle 12"/>
+          <p:cNvSpPr/>
+          <p:nvPr/>
+        </p:nvSpPr>
+        <p:spPr>
+          <a:xfrm>
+            <a:off x="8101584" y="1600200"/>
+            <a:ext cx="3328416" cy="73152"/>
+          </a:xfrm>
+          <a:prstGeom prst="roundRect">
+            <a:avLst/>
+          </a:prstGeom>
+          <a:solidFill>
+            <a:srgbClr val="1B4332"/>
+          </a:solidFill>
+          <a:ln>
+            <a:noFill/>
+          </a:ln>
+        </p:spPr>
+        <p:style>
+          <a:lnRef idx="1">
+            <a:schemeClr val="accent1"/>
+          </a:lnRef>
+          <a:fillRef idx="3">
+            <a:schemeClr val="accent1"/>
+          </a:fillRef>
+          <a:effectRef idx="2">
+            <a:schemeClr val="accent1"/>
+          </a:effectRef>
+          <a:fontRef idx="minor">
+            <a:schemeClr val="lt1"/>
+          </a:fontRef>
+        </p:style>
+        <p:txBody>
+          <a:bodyPr rtlCol="0" anchor="ctr"/>
+          <a:lstStyle/>
+          <a:p>
+            <a:pPr algn="ctr"/>
+          </a:p>
+        </p:txBody>
+      </p:sp>
+      <p:sp>
+        <p:nvSpPr>
+          <p:cNvPr id="14" name="TextBox 13"/>
+          <p:cNvSpPr txBox="1"/>
+          <p:nvPr/>
+        </p:nvSpPr>
+        <p:spPr>
+          <a:xfrm>
+            <a:off x="8321040" y="1819656"/>
+            <a:ext cx="2889504" cy="3950208"/>
+          </a:xfrm>
+          <a:prstGeom prst="rect">
+            <a:avLst/>
+          </a:prstGeom>
+          <a:noFill/>
+        </p:spPr>
+        <p:txBody>
+          <a:bodyPr wrap="square">
+            <a:spAutoFit/>
+          </a:bodyPr>
+          <a:lstStyle/>
+          <a:p>
+            <a:pPr>
+              <a:spcAft>
+                <a:spcPts val="800"/>
+              </a:spcAft>
+              <a:defRPr sz="1350" b="1">
+                <a:solidFill>
+                  <a:srgbClr val="1B4332"/>
+                </a:solidFill>
+              </a:defRPr>
+            </a:pPr>
+            <a:r>
+              <a:t>Phase 3: Full Enterprise Rollout</a:t>
+            </a:r>
+            <a:br/>
+            <a:r>
+              <a:t>(Month 4+)</a:t>
+            </a:r>
+          </a:p>
+          <a:p>
+            <a:pPr>
+              <a:spcAft>
+                <a:spcPts val="400"/>
+              </a:spcAft>
+              <a:defRPr sz="1100">
+                <a:solidFill>
+                  <a:srgbClr val="1E293B"/>
+                </a:solidFill>
+              </a:defRPr>
+            </a:pPr>
+            <a:r>
+              <a:t>• Multi-tenant Role-Based Access Control (RBAC) &amp; SSO.</a:t>
+            </a:r>
+          </a:p>
+          <a:p>
+            <a:pPr>
+              <a:spcAft>
+                <a:spcPts val="400"/>
+              </a:spcAft>
+              <a:defRPr sz="1100">
+                <a:solidFill>
+                  <a:srgbClr val="1E293B"/>
+                </a:solidFill>
+              </a:defRPr>
+            </a:pPr>
+            <a:r>
+              <a:t>• Transaction-level automated intercompany elimination.</a:t>
+            </a:r>
+          </a:p>
+          <a:p>
+            <a:pPr>
+              <a:spcAft>
+                <a:spcPts val="400"/>
+              </a:spcAft>
+              <a:defRPr sz="1100">
+                <a:solidFill>
+                  <a:srgbClr val="1E293B"/>
+                </a:solidFill>
+              </a:defRPr>
+            </a:pPr>
+            <a:r>
+              <a:t>• Dedicated secure portal for external audit review teams.</a:t>
+            </a:r>
+          </a:p>
+          <a:p>
+            <a:pPr>
+              <a:spcAft>
+                <a:spcPts val="400"/>
+              </a:spcAft>
+              <a:defRPr sz="1100">
+                <a:solidFill>
+                  <a:srgbClr val="1E293B"/>
+                </a:solidFill>
+              </a:defRPr>
+            </a:pPr>
+            <a:r>
+              <a:t>• Continuous group-wide financial health telemetry.</a:t>
+            </a:r>
+          </a:p>
+        </p:txBody>
+      </p:sp>
+    </p:spTree>
+  </p:cSld>
+  <p:clrMapOvr>
+    <a:masterClrMapping/>
+  </p:clrMapOvr>
+</p:sld>
+</file>
+
+<file path=ppt/slides/slide11.xml><?xml version="1.0" encoding="utf-8"?>
+<p:sld xmlns:a="http://schemas.openxmlformats.org/drawingml/2006/main" xmlns:p="http://schemas.openxmlformats.org/presentationml/2006/main" xmlns:r="http://schemas.openxmlformats.org/officeDocument/2006/relationships">
+  <p:cSld>
+    <p:spTree>
+      <p:nvGrpSpPr>
+        <p:cNvPr id="1" name=""/>
+        <p:cNvGrpSpPr/>
+        <p:nvPr/>
+      </p:nvGrpSpPr>
+      <p:grpSpPr/>
+      <p:sp>
+        <p:nvSpPr>
+          <p:cNvPr id="2" name="Rectangle 1"/>
+          <p:cNvSpPr/>
+          <p:nvPr/>
+        </p:nvSpPr>
+        <p:spPr>
+          <a:xfrm>
+            <a:off x="0" y="0"/>
+            <a:ext cx="12191695" cy="6858000"/>
+          </a:xfrm>
+          <a:prstGeom prst="rect">
+            <a:avLst/>
+          </a:prstGeom>
+          <a:solidFill>
+            <a:srgbClr val="FFFFFF"/>
+          </a:solidFill>
+          <a:ln>
+            <a:noFill/>
+          </a:ln>
+        </p:spPr>
+        <p:style>
+          <a:lnRef idx="1">
+            <a:schemeClr val="accent1"/>
+          </a:lnRef>
+          <a:fillRef idx="3">
+            <a:schemeClr val="accent1"/>
+          </a:fillRef>
+          <a:effectRef idx="2">
+            <a:schemeClr val="accent1"/>
+          </a:effectRef>
+          <a:fontRef idx="minor">
+            <a:schemeClr val="lt1"/>
+          </a:fontRef>
+        </p:style>
+        <p:txBody>
+          <a:bodyPr rtlCol="0" anchor="ctr"/>
+          <a:lstStyle/>
+          <a:p>
+            <a:pPr algn="ctr"/>
+          </a:p>
+        </p:txBody>
+      </p:sp>
+      <p:sp>
+        <p:nvSpPr>
+          <p:cNvPr id="3" name="Rectangle 2"/>
+          <p:cNvSpPr/>
+          <p:nvPr/>
+        </p:nvSpPr>
+        <p:spPr>
+          <a:xfrm>
+            <a:off x="731520" y="365760"/>
+            <a:ext cx="10728655" cy="36576"/>
+          </a:xfrm>
+          <a:prstGeom prst="rect">
+            <a:avLst/>
+          </a:prstGeom>
+          <a:solidFill>
+            <a:srgbClr val="1B4332"/>
+          </a:solidFill>
+          <a:ln>
+            <a:noFill/>
+          </a:ln>
+        </p:spPr>
+        <p:style>
+          <a:lnRef idx="1">
+            <a:schemeClr val="accent1"/>
+          </a:lnRef>
+          <a:fillRef idx="3">
+            <a:schemeClr val="accent1"/>
+          </a:fillRef>
+          <a:effectRef idx="2">
+            <a:schemeClr val="accent1"/>
+          </a:effectRef>
+          <a:fontRef idx="minor">
+            <a:schemeClr val="lt1"/>
+          </a:fontRef>
+        </p:style>
+        <p:txBody>
+          <a:bodyPr rtlCol="0" anchor="ctr"/>
+          <a:lstStyle/>
+          <a:p>
+            <a:pPr algn="ctr"/>
+          </a:p>
+        </p:txBody>
+      </p:sp>
+      <p:sp>
+        <p:nvSpPr>
+          <p:cNvPr id="4" name="TextBox 3"/>
+          <p:cNvSpPr txBox="1"/>
+          <p:nvPr/>
+        </p:nvSpPr>
+        <p:spPr>
+          <a:xfrm>
+            <a:off x="731520" y="502920"/>
+            <a:ext cx="9144000" cy="320040"/>
+          </a:xfrm>
+          <a:prstGeom prst="rect">
+            <a:avLst/>
+          </a:prstGeom>
+          <a:noFill/>
+        </p:spPr>
+        <p:txBody>
+          <a:bodyPr wrap="square">
+            <a:spAutoFit/>
+          </a:bodyPr>
+          <a:lstStyle/>
+          <a:p>
+            <a:pPr>
+              <a:defRPr sz="1000" b="1">
+                <a:solidFill>
+                  <a:srgbClr val="B48214"/>
+                </a:solidFill>
+              </a:defRPr>
+            </a:pPr>
+            <a:r>
               <a:t>STRATEGIC IMPACT</a:t>
             </a:r>
           </a:p>
@@ -4340,7 +5085,7 @@
               </a:defRPr>
             </a:pPr>
             <a:r>
-              <a:t>• Case in Point: Subsidiary II reported NCI profit share of $24.4M vs. statutory share of $18.2M (+34.1% gap).</a:t>
+              <a:t>• Case in Point: Subsidiary II reported NCI profit share of $24.4M vs statutory share of $18.2M (+34.1% gap).</a:t>
             </a:r>
           </a:p>
           <a:p>
@@ -4526,7 +5271,7 @@
               </a:defRPr>
             </a:pPr>
             <a:r>
-              <a:t>• Case in Point: Subsidiary II related-party receivables spiked +158.8% YoY while revenues grew just +4.9%.</a:t>
+              <a:t>• Case in Point: Subsidiary II related-party receivables spiked +158.8% YoY while revenue grew just +4.9%.</a:t>
             </a:r>
           </a:p>
           <a:p>
@@ -4556,7 +5301,7 @@
               </a:defRPr>
             </a:pPr>
             <a:r>
-              <a:t>• Increases intercompany elimination friction and triggers uncollectible debt exposure.</a:t>
+              <a:t>• Increases intercompany elimination friction and uncollectible debt exposure.</a:t>
             </a:r>
           </a:p>
         </p:txBody>
@@ -5087,7 +5832,7 @@
               </a:defRPr>
             </a:pPr>
             <a:r>
-              <a:t>• Statutory NCI Attribution: Precise IFRS 10 formulas calculate parent earnings vs. minority equity claims.</a:t>
+              <a:t>• Statutory NCI Attribution: Precise IFRS 10 formulas calculate parent earnings vs minority equity claims.</a:t>
             </a:r>
           </a:p>
           <a:p>
@@ -6486,7 +7231,7 @@
               </a:defRPr>
             </a:pPr>
             <a:r>
-              <a:t>QUANTITATIVE RULES</a:t>
+              <a:t>LIVE FINANCIAL METRICS</a:t>
             </a:r>
           </a:p>
         </p:txBody>
@@ -6521,7 +7266,7 @@
               </a:defRPr>
             </a:pPr>
             <a:r>
-              <a:t>Forensic Anomaly Detection Engine: Vectors &amp; Thresholds</a:t>
+              <a:t>Tool Output: Consolidated Financial KPI Dashboard</a:t>
             </a:r>
           </a:p>
         </p:txBody>
@@ -6535,7 +7280,7 @@
         <p:spPr>
           <a:xfrm>
             <a:off x="731520" y="1600200"/>
-            <a:ext cx="10728655" cy="1005840"/>
+            <a:ext cx="3328416" cy="1325880"/>
           </a:xfrm>
           <a:prstGeom prst="roundRect">
             <a:avLst/>
@@ -6580,13 +7325,13 @@
         <p:spPr>
           <a:xfrm>
             <a:off x="731520" y="1600200"/>
-            <a:ext cx="73152" cy="1005840"/>
+            <a:ext cx="73152" cy="1325880"/>
           </a:xfrm>
           <a:prstGeom prst="rect">
             <a:avLst/>
           </a:prstGeom>
           <a:solidFill>
-            <a:srgbClr val="E11D48"/>
+            <a:srgbClr val="1B4332"/>
           </a:solidFill>
           <a:ln>
             <a:noFill/>
@@ -6622,8 +7367,8 @@
         </p:nvSpPr>
         <p:spPr>
           <a:xfrm>
-            <a:off x="960120" y="1709928"/>
-            <a:ext cx="10332720" cy="786384"/>
+            <a:off x="896112" y="1691640"/>
+            <a:ext cx="3054096" cy="1143000"/>
           </a:xfrm>
           <a:prstGeom prst="rect">
             <a:avLst/>
@@ -6637,29 +7382,44 @@
           <a:lstStyle/>
           <a:p>
             <a:pPr>
-              <a:defRPr sz="1350" b="1">
-                <a:solidFill>
-                  <a:srgbClr val="E11D48"/>
-                </a:solidFill>
-              </a:defRPr>
-            </a:pPr>
-            <a:r>
-              <a:t>1. NCI Profit Allocation Disparity  [CRITICAL]</a:t>
+              <a:defRPr sz="1000" b="1">
+                <a:solidFill>
+                  <a:srgbClr val="64748B"/>
+                </a:solidFill>
+              </a:defRPr>
+            </a:pPr>
+            <a:r>
+              <a:t>CONSOLIDATED REVENUE</a:t>
             </a:r>
           </a:p>
           <a:p>
             <a:pPr>
               <a:spcBef>
-                <a:spcPts val="300"/>
+                <a:spcPts val="200"/>
               </a:spcBef>
-              <a:defRPr sz="1100">
-                <a:solidFill>
-                  <a:srgbClr val="1E293B"/>
-                </a:solidFill>
-              </a:defRPr>
-            </a:pPr>
-            <a:r>
-              <a:t>Formula: |Reported NCI - Computed NCI| &gt; 8%   •   Audit Objective: Prevents parent income distortion and safeguards minority shareholder dividend equity under IFRS 10 / PSAK 65.</a:t>
+              <a:defRPr sz="1800" b="1">
+                <a:solidFill>
+                  <a:srgbClr val="0F172A"/>
+                </a:solidFill>
+              </a:defRPr>
+            </a:pPr>
+            <a:r>
+              <a:t>$3,885.0 M</a:t>
+            </a:r>
+          </a:p>
+          <a:p>
+            <a:pPr>
+              <a:spcBef>
+                <a:spcPts val="200"/>
+              </a:spcBef>
+              <a:defRPr sz="1000">
+                <a:solidFill>
+                  <a:srgbClr val="1B4332"/>
+                </a:solidFill>
+              </a:defRPr>
+            </a:pPr>
+            <a:r>
+              <a:t>PY: $3,635.0 M (+6.9% YoY)</a:t>
             </a:r>
           </a:p>
         </p:txBody>
@@ -6672,8 +7432,8 @@
         </p:nvSpPr>
         <p:spPr>
           <a:xfrm>
-            <a:off x="731520" y="2743200"/>
-            <a:ext cx="10728655" cy="1005840"/>
+            <a:off x="4416552" y="1600200"/>
+            <a:ext cx="3328416" cy="1325880"/>
           </a:xfrm>
           <a:prstGeom prst="roundRect">
             <a:avLst/>
@@ -6717,14 +7477,14 @@
         </p:nvSpPr>
         <p:spPr>
           <a:xfrm>
-            <a:off x="731520" y="2743200"/>
-            <a:ext cx="73152" cy="1005840"/>
+            <a:off x="4416552" y="1600200"/>
+            <a:ext cx="73152" cy="1325880"/>
           </a:xfrm>
           <a:prstGeom prst="rect">
             <a:avLst/>
           </a:prstGeom>
           <a:solidFill>
-            <a:srgbClr val="E11D48"/>
+            <a:srgbClr val="1B4332"/>
           </a:solidFill>
           <a:ln>
             <a:noFill/>
@@ -6760,8 +7520,8 @@
         </p:nvSpPr>
         <p:spPr>
           <a:xfrm>
-            <a:off x="960120" y="2852928"/>
-            <a:ext cx="10332720" cy="786384"/>
+            <a:off x="4581144" y="1691640"/>
+            <a:ext cx="3054096" cy="1143000"/>
           </a:xfrm>
           <a:prstGeom prst="rect">
             <a:avLst/>
@@ -6775,29 +7535,44 @@
           <a:lstStyle/>
           <a:p>
             <a:pPr>
-              <a:defRPr sz="1350" b="1">
-                <a:solidFill>
-                  <a:srgbClr val="E11D48"/>
-                </a:solidFill>
-              </a:defRPr>
-            </a:pPr>
-            <a:r>
-              <a:t>2. Related-Party Debt Acceleration  [CRITICAL]</a:t>
+              <a:defRPr sz="1000" b="1">
+                <a:solidFill>
+                  <a:srgbClr val="64748B"/>
+                </a:solidFill>
+              </a:defRPr>
+            </a:pPr>
+            <a:r>
+              <a:t>CONSOLIDATED NET INCOME</a:t>
             </a:r>
           </a:p>
           <a:p>
             <a:pPr>
               <a:spcBef>
-                <a:spcPts val="300"/>
+                <a:spcPts val="200"/>
               </a:spcBef>
-              <a:defRPr sz="1100">
-                <a:solidFill>
-                  <a:srgbClr val="1E293B"/>
-                </a:solidFill>
-              </a:defRPr>
-            </a:pPr>
-            <a:r>
-              <a:t>Formula: ΔRP Receivables - ΔRevenue &gt; 30%   •   Audit Objective: Detects liquidity outflows into affiliated entities and halts hidden internal non-performing debt under IAS 24 / PSAK 7.</a:t>
+              <a:defRPr sz="1800" b="1">
+                <a:solidFill>
+                  <a:srgbClr val="0F172A"/>
+                </a:solidFill>
+              </a:defRPr>
+            </a:pPr>
+            <a:r>
+              <a:t>$325.0 M</a:t>
+            </a:r>
+          </a:p>
+          <a:p>
+            <a:pPr>
+              <a:spcBef>
+                <a:spcPts val="200"/>
+              </a:spcBef>
+              <a:defRPr sz="1000">
+                <a:solidFill>
+                  <a:srgbClr val="1B4332"/>
+                </a:solidFill>
+              </a:defRPr>
+            </a:pPr>
+            <a:r>
+              <a:t>PY: $284.7 M (+14.2% YoY)</a:t>
             </a:r>
           </a:p>
         </p:txBody>
@@ -6810,8 +7585,8 @@
         </p:nvSpPr>
         <p:spPr>
           <a:xfrm>
-            <a:off x="731520" y="3886200"/>
-            <a:ext cx="10728655" cy="1005840"/>
+            <a:off x="8101584" y="1600200"/>
+            <a:ext cx="3328416" cy="1325880"/>
           </a:xfrm>
           <a:prstGeom prst="roundRect">
             <a:avLst/>
@@ -6855,14 +7630,14 @@
         </p:nvSpPr>
         <p:spPr>
           <a:xfrm>
-            <a:off x="731520" y="3886200"/>
-            <a:ext cx="73152" cy="1005840"/>
+            <a:off x="8101584" y="1600200"/>
+            <a:ext cx="73152" cy="1325880"/>
           </a:xfrm>
           <a:prstGeom prst="rect">
             <a:avLst/>
           </a:prstGeom>
           <a:solidFill>
-            <a:srgbClr val="D97706"/>
+            <a:srgbClr val="B48214"/>
           </a:solidFill>
           <a:ln>
             <a:noFill/>
@@ -6898,8 +7673,8 @@
         </p:nvSpPr>
         <p:spPr>
           <a:xfrm>
-            <a:off x="960120" y="3995928"/>
-            <a:ext cx="10332720" cy="786384"/>
+            <a:off x="8266176" y="1691640"/>
+            <a:ext cx="3054096" cy="1143000"/>
           </a:xfrm>
           <a:prstGeom prst="rect">
             <a:avLst/>
@@ -6913,29 +7688,44 @@
           <a:lstStyle/>
           <a:p>
             <a:pPr>
-              <a:defRPr sz="1350" b="1">
-                <a:solidFill>
-                  <a:srgbClr val="D97706"/>
-                </a:solidFill>
-              </a:defRPr>
-            </a:pPr>
-            <a:r>
-              <a:t>3. Sudden Leverage / DER Escalation  [MEDIUM]</a:t>
+              <a:defRPr sz="1000" b="1">
+                <a:solidFill>
+                  <a:srgbClr val="64748B"/>
+                </a:solidFill>
+              </a:defRPr>
+            </a:pPr>
+            <a:r>
+              <a:t>PARENT ATTRIBUTABLE INCOME</a:t>
             </a:r>
           </a:p>
           <a:p>
             <a:pPr>
               <a:spcBef>
-                <a:spcPts val="300"/>
+                <a:spcPts val="200"/>
               </a:spcBef>
-              <a:defRPr sz="1100">
-                <a:solidFill>
-                  <a:srgbClr val="1E293B"/>
-                </a:solidFill>
-              </a:defRPr>
-            </a:pPr>
-            <a:r>
-              <a:t>Formula: DER CY / DER PY - 1 &gt; 18%   •   Audit Objective: Monitors subsidiary debt growth before debt-to-equity ratios breach bank debt covenants or regulatory limits.</a:t>
+              <a:defRPr sz="1800" b="1">
+                <a:solidFill>
+                  <a:srgbClr val="0F172A"/>
+                </a:solidFill>
+              </a:defRPr>
+            </a:pPr>
+            <a:r>
+              <a:t>$279.7 M</a:t>
+            </a:r>
+          </a:p>
+          <a:p>
+            <a:pPr>
+              <a:spcBef>
+                <a:spcPts val="200"/>
+              </a:spcBef>
+              <a:defRPr sz="1000">
+                <a:solidFill>
+                  <a:srgbClr val="B48214"/>
+                </a:solidFill>
+              </a:defRPr>
+            </a:pPr>
+            <a:r>
+              <a:t>86.1% share of net profits</a:t>
             </a:r>
           </a:p>
         </p:txBody>
@@ -6948,8 +7738,8 @@
         </p:nvSpPr>
         <p:spPr>
           <a:xfrm>
-            <a:off x="731520" y="5029200"/>
-            <a:ext cx="10728655" cy="1005840"/>
+            <a:off x="731520" y="3063240"/>
+            <a:ext cx="3328416" cy="1325880"/>
           </a:xfrm>
           <a:prstGeom prst="roundRect">
             <a:avLst/>
@@ -6993,14 +7783,14 @@
         </p:nvSpPr>
         <p:spPr>
           <a:xfrm>
-            <a:off x="731520" y="5029200"/>
-            <a:ext cx="73152" cy="1005840"/>
+            <a:off x="731520" y="3063240"/>
+            <a:ext cx="73152" cy="1325880"/>
           </a:xfrm>
           <a:prstGeom prst="rect">
             <a:avLst/>
           </a:prstGeom>
           <a:solidFill>
-            <a:srgbClr val="0D9488"/>
+            <a:srgbClr val="D97706"/>
           </a:solidFill>
           <a:ln>
             <a:noFill/>
@@ -7036,8 +7826,8 @@
         </p:nvSpPr>
         <p:spPr>
           <a:xfrm>
-            <a:off x="960120" y="5138928"/>
-            <a:ext cx="10332720" cy="786384"/>
+            <a:off x="896112" y="3154680"/>
+            <a:ext cx="3054096" cy="1143000"/>
           </a:xfrm>
           <a:prstGeom prst="rect">
             <a:avLst/>
@@ -7051,20 +7841,436 @@
           <a:lstStyle/>
           <a:p>
             <a:pPr>
-              <a:defRPr sz="1350" b="1">
+              <a:defRPr sz="1000" b="1">
+                <a:solidFill>
+                  <a:srgbClr val="64748B"/>
+                </a:solidFill>
+              </a:defRPr>
+            </a:pPr>
+            <a:r>
+              <a:t>NCI MINORITY PROFIT SHARE</a:t>
+            </a:r>
+          </a:p>
+          <a:p>
+            <a:pPr>
+              <a:spcBef>
+                <a:spcPts val="200"/>
+              </a:spcBef>
+              <a:defRPr sz="1800" b="1">
+                <a:solidFill>
+                  <a:srgbClr val="0F172A"/>
+                </a:solidFill>
+              </a:defRPr>
+            </a:pPr>
+            <a:r>
+              <a:t>$45.3 M</a:t>
+            </a:r>
+          </a:p>
+          <a:p>
+            <a:pPr>
+              <a:spcBef>
+                <a:spcPts val="200"/>
+              </a:spcBef>
+              <a:defRPr sz="1000">
+                <a:solidFill>
+                  <a:srgbClr val="D97706"/>
+                </a:solidFill>
+              </a:defRPr>
+            </a:pPr>
+            <a:r>
+              <a:t>13.9% across 4 subsidiaries</a:t>
+            </a:r>
+          </a:p>
+        </p:txBody>
+      </p:sp>
+      <p:sp>
+        <p:nvSpPr>
+          <p:cNvPr id="18" name="Rounded Rectangle 17"/>
+          <p:cNvSpPr/>
+          <p:nvPr/>
+        </p:nvSpPr>
+        <p:spPr>
+          <a:xfrm>
+            <a:off x="4416552" y="3063240"/>
+            <a:ext cx="3328416" cy="1325880"/>
+          </a:xfrm>
+          <a:prstGeom prst="roundRect">
+            <a:avLst/>
+          </a:prstGeom>
+          <a:solidFill>
+            <a:srgbClr val="F8FAFC"/>
+          </a:solidFill>
+          <a:ln>
+            <a:solidFill>
+              <a:srgbClr val="E2E8F0"/>
+            </a:solidFill>
+          </a:ln>
+        </p:spPr>
+        <p:style>
+          <a:lnRef idx="1">
+            <a:schemeClr val="accent1"/>
+          </a:lnRef>
+          <a:fillRef idx="3">
+            <a:schemeClr val="accent1"/>
+          </a:fillRef>
+          <a:effectRef idx="2">
+            <a:schemeClr val="accent1"/>
+          </a:effectRef>
+          <a:fontRef idx="minor">
+            <a:schemeClr val="lt1"/>
+          </a:fontRef>
+        </p:style>
+        <p:txBody>
+          <a:bodyPr rtlCol="0" anchor="ctr"/>
+          <a:lstStyle/>
+          <a:p>
+            <a:pPr algn="ctr"/>
+          </a:p>
+        </p:txBody>
+      </p:sp>
+      <p:sp>
+        <p:nvSpPr>
+          <p:cNvPr id="19" name="Rectangle 18"/>
+          <p:cNvSpPr/>
+          <p:nvPr/>
+        </p:nvSpPr>
+        <p:spPr>
+          <a:xfrm>
+            <a:off x="4416552" y="3063240"/>
+            <a:ext cx="73152" cy="1325880"/>
+          </a:xfrm>
+          <a:prstGeom prst="rect">
+            <a:avLst/>
+          </a:prstGeom>
+          <a:solidFill>
+            <a:srgbClr val="0F172A"/>
+          </a:solidFill>
+          <a:ln>
+            <a:noFill/>
+          </a:ln>
+        </p:spPr>
+        <p:style>
+          <a:lnRef idx="1">
+            <a:schemeClr val="accent1"/>
+          </a:lnRef>
+          <a:fillRef idx="3">
+            <a:schemeClr val="accent1"/>
+          </a:fillRef>
+          <a:effectRef idx="2">
+            <a:schemeClr val="accent1"/>
+          </a:effectRef>
+          <a:fontRef idx="minor">
+            <a:schemeClr val="lt1"/>
+          </a:fontRef>
+        </p:style>
+        <p:txBody>
+          <a:bodyPr rtlCol="0" anchor="ctr"/>
+          <a:lstStyle/>
+          <a:p>
+            <a:pPr algn="ctr"/>
+          </a:p>
+        </p:txBody>
+      </p:sp>
+      <p:sp>
+        <p:nvSpPr>
+          <p:cNvPr id="20" name="TextBox 19"/>
+          <p:cNvSpPr txBox="1"/>
+          <p:nvPr/>
+        </p:nvSpPr>
+        <p:spPr>
+          <a:xfrm>
+            <a:off x="4581144" y="3154680"/>
+            <a:ext cx="3054096" cy="1143000"/>
+          </a:xfrm>
+          <a:prstGeom prst="rect">
+            <a:avLst/>
+          </a:prstGeom>
+          <a:noFill/>
+        </p:spPr>
+        <p:txBody>
+          <a:bodyPr wrap="square">
+            <a:spAutoFit/>
+          </a:bodyPr>
+          <a:lstStyle/>
+          <a:p>
+            <a:pPr>
+              <a:defRPr sz="1000" b="1">
+                <a:solidFill>
+                  <a:srgbClr val="64748B"/>
+                </a:solidFill>
+              </a:defRPr>
+            </a:pPr>
+            <a:r>
+              <a:t>CONSOLIDATED TOTAL ASSETS</a:t>
+            </a:r>
+          </a:p>
+          <a:p>
+            <a:pPr>
+              <a:spcBef>
+                <a:spcPts val="200"/>
+              </a:spcBef>
+              <a:defRPr sz="1800" b="1">
+                <a:solidFill>
+                  <a:srgbClr val="0F172A"/>
+                </a:solidFill>
+              </a:defRPr>
+            </a:pPr>
+            <a:r>
+              <a:t>$6,000.0 M</a:t>
+            </a:r>
+          </a:p>
+          <a:p>
+            <a:pPr>
+              <a:spcBef>
+                <a:spcPts val="200"/>
+              </a:spcBef>
+              <a:defRPr sz="1000">
+                <a:solidFill>
+                  <a:srgbClr val="0F172A"/>
+                </a:solidFill>
+              </a:defRPr>
+            </a:pPr>
+            <a:r>
+              <a:t>ROA: 5.4% (Industry top-quartile)</a:t>
+            </a:r>
+          </a:p>
+        </p:txBody>
+      </p:sp>
+      <p:sp>
+        <p:nvSpPr>
+          <p:cNvPr id="21" name="Rounded Rectangle 20"/>
+          <p:cNvSpPr/>
+          <p:nvPr/>
+        </p:nvSpPr>
+        <p:spPr>
+          <a:xfrm>
+            <a:off x="8101584" y="3063240"/>
+            <a:ext cx="3328416" cy="1325880"/>
+          </a:xfrm>
+          <a:prstGeom prst="roundRect">
+            <a:avLst/>
+          </a:prstGeom>
+          <a:solidFill>
+            <a:srgbClr val="F8FAFC"/>
+          </a:solidFill>
+          <a:ln>
+            <a:solidFill>
+              <a:srgbClr val="E2E8F0"/>
+            </a:solidFill>
+          </a:ln>
+        </p:spPr>
+        <p:style>
+          <a:lnRef idx="1">
+            <a:schemeClr val="accent1"/>
+          </a:lnRef>
+          <a:fillRef idx="3">
+            <a:schemeClr val="accent1"/>
+          </a:fillRef>
+          <a:effectRef idx="2">
+            <a:schemeClr val="accent1"/>
+          </a:effectRef>
+          <a:fontRef idx="minor">
+            <a:schemeClr val="lt1"/>
+          </a:fontRef>
+        </p:style>
+        <p:txBody>
+          <a:bodyPr rtlCol="0" anchor="ctr"/>
+          <a:lstStyle/>
+          <a:p>
+            <a:pPr algn="ctr"/>
+          </a:p>
+        </p:txBody>
+      </p:sp>
+      <p:sp>
+        <p:nvSpPr>
+          <p:cNvPr id="22" name="Rectangle 21"/>
+          <p:cNvSpPr/>
+          <p:nvPr/>
+        </p:nvSpPr>
+        <p:spPr>
+          <a:xfrm>
+            <a:off x="8101584" y="3063240"/>
+            <a:ext cx="73152" cy="1325880"/>
+          </a:xfrm>
+          <a:prstGeom prst="rect">
+            <a:avLst/>
+          </a:prstGeom>
+          <a:solidFill>
+            <a:srgbClr val="0D9488"/>
+          </a:solidFill>
+          <a:ln>
+            <a:noFill/>
+          </a:ln>
+        </p:spPr>
+        <p:style>
+          <a:lnRef idx="1">
+            <a:schemeClr val="accent1"/>
+          </a:lnRef>
+          <a:fillRef idx="3">
+            <a:schemeClr val="accent1"/>
+          </a:fillRef>
+          <a:effectRef idx="2">
+            <a:schemeClr val="accent1"/>
+          </a:effectRef>
+          <a:fontRef idx="minor">
+            <a:schemeClr val="lt1"/>
+          </a:fontRef>
+        </p:style>
+        <p:txBody>
+          <a:bodyPr rtlCol="0" anchor="ctr"/>
+          <a:lstStyle/>
+          <a:p>
+            <a:pPr algn="ctr"/>
+          </a:p>
+        </p:txBody>
+      </p:sp>
+      <p:sp>
+        <p:nvSpPr>
+          <p:cNvPr id="23" name="TextBox 22"/>
+          <p:cNvSpPr txBox="1"/>
+          <p:nvPr/>
+        </p:nvSpPr>
+        <p:spPr>
+          <a:xfrm>
+            <a:off x="8266176" y="3154680"/>
+            <a:ext cx="3054096" cy="1143000"/>
+          </a:xfrm>
+          <a:prstGeom prst="rect">
+            <a:avLst/>
+          </a:prstGeom>
+          <a:noFill/>
+        </p:spPr>
+        <p:txBody>
+          <a:bodyPr wrap="square">
+            <a:spAutoFit/>
+          </a:bodyPr>
+          <a:lstStyle/>
+          <a:p>
+            <a:pPr>
+              <a:defRPr sz="1000" b="1">
+                <a:solidFill>
+                  <a:srgbClr val="64748B"/>
+                </a:solidFill>
+              </a:defRPr>
+            </a:pPr>
+            <a:r>
+              <a:t>CONSOLIDATED SOLVENCY (DER)</a:t>
+            </a:r>
+          </a:p>
+          <a:p>
+            <a:pPr>
+              <a:spcBef>
+                <a:spcPts val="200"/>
+              </a:spcBef>
+              <a:defRPr sz="1800" b="1">
+                <a:solidFill>
+                  <a:srgbClr val="0F172A"/>
+                </a:solidFill>
+              </a:defRPr>
+            </a:pPr>
+            <a:r>
+              <a:t>0.96x</a:t>
+            </a:r>
+          </a:p>
+          <a:p>
+            <a:pPr>
+              <a:spcBef>
+                <a:spcPts val="200"/>
+              </a:spcBef>
+              <a:defRPr sz="1000">
                 <a:solidFill>
                   <a:srgbClr val="0D9488"/>
                 </a:solidFill>
               </a:defRPr>
             </a:pPr>
             <a:r>
-              <a:t>4. Profit Margin Distortion  [MODERATE]</a:t>
+              <a:t>PY: 0.94x (POJK Max: 5.0x Safe)</a:t>
+            </a:r>
+          </a:p>
+        </p:txBody>
+      </p:sp>
+      <p:sp>
+        <p:nvSpPr>
+          <p:cNvPr id="24" name="Rounded Rectangle 23"/>
+          <p:cNvSpPr/>
+          <p:nvPr/>
+        </p:nvSpPr>
+        <p:spPr>
+          <a:xfrm>
+            <a:off x="731520" y="4663440"/>
+            <a:ext cx="10728655" cy="1645920"/>
+          </a:xfrm>
+          <a:prstGeom prst="roundRect">
+            <a:avLst/>
+          </a:prstGeom>
+          <a:solidFill>
+            <a:srgbClr val="F8FAFC"/>
+          </a:solidFill>
+          <a:ln>
+            <a:solidFill>
+              <a:srgbClr val="E2E8F0"/>
+            </a:solidFill>
+          </a:ln>
+        </p:spPr>
+        <p:style>
+          <a:lnRef idx="1">
+            <a:schemeClr val="accent1"/>
+          </a:lnRef>
+          <a:fillRef idx="3">
+            <a:schemeClr val="accent1"/>
+          </a:fillRef>
+          <a:effectRef idx="2">
+            <a:schemeClr val="accent1"/>
+          </a:effectRef>
+          <a:fontRef idx="minor">
+            <a:schemeClr val="lt1"/>
+          </a:fontRef>
+        </p:style>
+        <p:txBody>
+          <a:bodyPr rtlCol="0" anchor="ctr"/>
+          <a:lstStyle/>
+          <a:p>
+            <a:pPr algn="ctr"/>
+          </a:p>
+        </p:txBody>
+      </p:sp>
+      <p:sp>
+        <p:nvSpPr>
+          <p:cNvPr id="25" name="TextBox 24"/>
+          <p:cNvSpPr txBox="1"/>
+          <p:nvPr/>
+        </p:nvSpPr>
+        <p:spPr>
+          <a:xfrm>
+            <a:off x="914400" y="4754880"/>
+            <a:ext cx="10332720" cy="1463040"/>
+          </a:xfrm>
+          <a:prstGeom prst="rect">
+            <a:avLst/>
+          </a:prstGeom>
+          <a:noFill/>
+        </p:spPr>
+        <p:txBody>
+          <a:bodyPr wrap="square">
+            <a:spAutoFit/>
+          </a:bodyPr>
+          <a:lstStyle/>
+          <a:p>
+            <a:pPr>
+              <a:defRPr sz="1100" b="1">
+                <a:solidFill>
+                  <a:srgbClr val="0F172A"/>
+                </a:solidFill>
+              </a:defRPr>
+            </a:pPr>
+            <a:r>
+              <a:t>NET INCOME CONTRIBUTION BREAKDOWN ACROSS 6 ENTITIES</a:t>
             </a:r>
           </a:p>
           <a:p>
             <a:pPr>
               <a:spcBef>
-                <a:spcPts val="300"/>
+                <a:spcPts val="600"/>
               </a:spcBef>
               <a:defRPr sz="1100">
                 <a:solidFill>
@@ -7073,7 +8279,15 @@
               </a:defRPr>
             </a:pPr>
             <a:r>
-              <a:t>Formula: |Margin CY - Margin PY| ≥ 3.5 pp   •   Audit Objective: Verifies whether margin expansion/compression stems from genuine operations or one-off artificial transactions.</a:t>
+              <a:t>• Yayasan Holding (Induk): $64.0M (19.7%)    • Subsidiary I (100% Control): $118.0M (36.3%)</a:t>
+            </a:r>
+            <a:br/>
+            <a:r>
+              <a:t>• Subsidiary II (35% NCI): $52.0M (16.0%)     • Subsidiary III (40% NCI): $31.0M (9.5%)</a:t>
+            </a:r>
+            <a:br/>
+            <a:r>
+              <a:t>• Subsidiary IV (22% NCI): $41.0M (12.6%)     • Subsidiary V (30% NCI): $19.0M (5.8%)</a:t>
             </a:r>
           </a:p>
         </p:txBody>
@@ -7212,7 +8426,7 @@
               </a:defRPr>
             </a:pPr>
             <a:r>
-              <a:t>AUDIT OPERATIONS</a:t>
+              <a:t>REVIEW WORKSPACE</a:t>
             </a:r>
           </a:p>
         </p:txBody>
@@ -7247,7 +8461,7 @@
               </a:defRPr>
             </a:pPr>
             <a:r>
-              <a:t>Actionable Review Workspace: Human-in-the-Loop Workflow</a:t>
+              <a:t>Tool Output: Items Requiring Review (Findings &amp; Decisions)</a:t>
             </a:r>
           </a:p>
         </p:txBody>
@@ -7261,7 +8475,7 @@
         <p:spPr>
           <a:xfrm>
             <a:off x="731520" y="1600200"/>
-            <a:ext cx="2560320" cy="4389120"/>
+            <a:ext cx="10728655" cy="1005840"/>
           </a:xfrm>
           <a:prstGeom prst="roundRect">
             <a:avLst/>
@@ -7269,7 +8483,7 @@
           <a:solidFill>
             <a:srgbClr val="F8FAFC"/>
           </a:solidFill>
-          <a:ln w="12700">
+          <a:ln>
             <a:solidFill>
               <a:srgbClr val="E2E8F0"/>
             </a:solidFill>
@@ -7299,16 +8513,16 @@
       </p:sp>
       <p:sp>
         <p:nvSpPr>
-          <p:cNvPr id="7" name="Rounded Rectangle 6"/>
+          <p:cNvPr id="7" name="Rectangle 6"/>
           <p:cNvSpPr/>
           <p:nvPr/>
         </p:nvSpPr>
         <p:spPr>
           <a:xfrm>
             <a:off x="731520" y="1600200"/>
-            <a:ext cx="2560320" cy="73152"/>
-          </a:xfrm>
-          <a:prstGeom prst="roundRect">
+            <a:ext cx="73152" cy="1005840"/>
+          </a:xfrm>
+          <a:prstGeom prst="rect">
             <a:avLst/>
           </a:prstGeom>
           <a:solidFill>
@@ -7348,8 +8562,8 @@
         </p:nvSpPr>
         <p:spPr>
           <a:xfrm>
-            <a:off x="950976" y="1819656"/>
-            <a:ext cx="2121408" cy="3950208"/>
+            <a:off x="960120" y="1673352"/>
+            <a:ext cx="10332720" cy="868680"/>
           </a:xfrm>
           <a:prstGeom prst="rect">
             <a:avLst/>
@@ -7363,62 +8577,29 @@
           <a:lstStyle/>
           <a:p>
             <a:pPr>
-              <a:spcAft>
-                <a:spcPts val="800"/>
-              </a:spcAft>
-              <a:defRPr sz="1350" b="1">
+              <a:defRPr sz="1250" b="1">
                 <a:solidFill>
                   <a:srgbClr val="E11D48"/>
                 </a:solidFill>
               </a:defRPr>
             </a:pPr>
             <a:r>
-              <a:t>Step 1: Automated Flagging</a:t>
-            </a:r>
-          </a:p>
-          <a:p>
-            <a:pPr>
-              <a:spcAft>
-                <a:spcPts val="400"/>
-              </a:spcAft>
-              <a:defRPr sz="1100">
+              <a:t>#1. NCI Allocation Mismatch — Subsidiary II  [CRITICAL]  •  Status: Needs Management Clarification</a:t>
+            </a:r>
+          </a:p>
+          <a:p>
+            <a:pPr>
+              <a:spcBef>
+                <a:spcPts val="300"/>
+              </a:spcBef>
+              <a:defRPr sz="1050">
                 <a:solidFill>
                   <a:srgbClr val="1E293B"/>
                 </a:solidFill>
               </a:defRPr>
             </a:pPr>
             <a:r>
-              <a:t>• Rule Engine scans all 6 entities instantly.</a:t>
-            </a:r>
-          </a:p>
-          <a:p>
-            <a:pPr>
-              <a:spcAft>
-                <a:spcPts val="400"/>
-              </a:spcAft>
-              <a:defRPr sz="1100">
-                <a:solidFill>
-                  <a:srgbClr val="1E293B"/>
-                </a:solidFill>
-              </a:defRPr>
-            </a:pPr>
-            <a:r>
-              <a:t>• Anomalies classified by severity: Critical, Medium, Moderate.</a:t>
-            </a:r>
-          </a:p>
-          <a:p>
-            <a:pPr>
-              <a:spcAft>
-                <a:spcPts val="400"/>
-              </a:spcAft>
-              <a:defRPr sz="1100">
-                <a:solidFill>
-                  <a:srgbClr val="1E293B"/>
-                </a:solidFill>
-              </a:defRPr>
-            </a:pPr>
-            <a:r>
-              <a:t>• Dynamic badges populate the review dashboard.</a:t>
+              <a:t>Quantified Delta: Reported $24.4M vs Computed $18.2M (+34.1% gap)   |   Audit Impact: Understatement of parent attributable earnings; potential disguised dividend allocation.</a:t>
             </a:r>
           </a:p>
         </p:txBody>
@@ -7431,8 +8612,8 @@
         </p:nvSpPr>
         <p:spPr>
           <a:xfrm>
-            <a:off x="3438144" y="1600200"/>
-            <a:ext cx="2560320" cy="4389120"/>
+            <a:off x="731520" y="2743200"/>
+            <a:ext cx="10728655" cy="1005840"/>
           </a:xfrm>
           <a:prstGeom prst="roundRect">
             <a:avLst/>
@@ -7440,7 +8621,7 @@
           <a:solidFill>
             <a:srgbClr val="F8FAFC"/>
           </a:solidFill>
-          <a:ln w="12700">
+          <a:ln>
             <a:solidFill>
               <a:srgbClr val="E2E8F0"/>
             </a:solidFill>
@@ -7470,20 +8651,20 @@
       </p:sp>
       <p:sp>
         <p:nvSpPr>
-          <p:cNvPr id="10" name="Rounded Rectangle 9"/>
+          <p:cNvPr id="10" name="Rectangle 9"/>
           <p:cNvSpPr/>
           <p:nvPr/>
         </p:nvSpPr>
         <p:spPr>
           <a:xfrm>
-            <a:off x="3438144" y="1600200"/>
-            <a:ext cx="2560320" cy="73152"/>
-          </a:xfrm>
-          <a:prstGeom prst="roundRect">
-            <a:avLst/>
-          </a:prstGeom>
-          <a:solidFill>
-            <a:srgbClr val="B48214"/>
+            <a:off x="731520" y="2743200"/>
+            <a:ext cx="73152" cy="1005840"/>
+          </a:xfrm>
+          <a:prstGeom prst="rect">
+            <a:avLst/>
+          </a:prstGeom>
+          <a:solidFill>
+            <a:srgbClr val="E11D48"/>
           </a:solidFill>
           <a:ln>
             <a:noFill/>
@@ -7519,8 +8700,8 @@
         </p:nvSpPr>
         <p:spPr>
           <a:xfrm>
-            <a:off x="3657600" y="1819656"/>
-            <a:ext cx="2121408" cy="3950208"/>
+            <a:off x="960120" y="2816352"/>
+            <a:ext cx="10332720" cy="868680"/>
           </a:xfrm>
           <a:prstGeom prst="rect">
             <a:avLst/>
@@ -7534,62 +8715,29 @@
           <a:lstStyle/>
           <a:p>
             <a:pPr>
-              <a:spcAft>
-                <a:spcPts val="800"/>
-              </a:spcAft>
-              <a:defRPr sz="1350" b="1">
-                <a:solidFill>
-                  <a:srgbClr val="B48214"/>
-                </a:solidFill>
-              </a:defRPr>
-            </a:pPr>
-            <a:r>
-              <a:t>Step 2: AI Reasoning &amp; Impact</a:t>
-            </a:r>
-          </a:p>
-          <a:p>
-            <a:pPr>
-              <a:spcAft>
-                <a:spcPts val="400"/>
-              </a:spcAft>
-              <a:defRPr sz="1100">
+              <a:defRPr sz="1250" b="1">
+                <a:solidFill>
+                  <a:srgbClr val="E11D48"/>
+                </a:solidFill>
+              </a:defRPr>
+            </a:pPr>
+            <a:r>
+              <a:t>#2. Related-Party Receivable Surge — Subsidiary II  [CRITICAL]  •  Status: Audit Finding (Requires Revision)</a:t>
+            </a:r>
+          </a:p>
+          <a:p>
+            <a:pPr>
+              <a:spcBef>
+                <a:spcPts val="300"/>
+              </a:spcBef>
+              <a:defRPr sz="1050">
                 <a:solidFill>
                   <a:srgbClr val="1E293B"/>
                 </a:solidFill>
               </a:defRPr>
             </a:pPr>
             <a:r>
-              <a:t>• AI Agent derives analytical root causes and accounting impact.</a:t>
-            </a:r>
-          </a:p>
-          <a:p>
-            <a:pPr>
-              <a:spcAft>
-                <a:spcPts val="400"/>
-              </a:spcAft>
-              <a:defRPr sz="1100">
-                <a:solidFill>
-                  <a:srgbClr val="1E293B"/>
-                </a:solidFill>
-              </a:defRPr>
-            </a:pPr>
-            <a:r>
-              <a:t>• Relevant IFRS 10 / IAS 24 standards cited.</a:t>
-            </a:r>
-          </a:p>
-          <a:p>
-            <a:pPr>
-              <a:spcAft>
-                <a:spcPts val="400"/>
-              </a:spcAft>
-              <a:defRPr sz="1100">
-                <a:solidFill>
-                  <a:srgbClr val="1E293B"/>
-                </a:solidFill>
-              </a:defRPr>
-            </a:pPr>
-            <a:r>
-              <a:t>• Conversational Copilot delivers instant executive briefs.</a:t>
+              <a:t>Quantified Delta: RP Receivables spiked +158.8% YoY vs Revenue +4.9%   |   Audit Impact: Risk of unmonitored capital transfer to affiliates under non-arms-length terms.</a:t>
             </a:r>
           </a:p>
         </p:txBody>
@@ -7602,8 +8750,8 @@
         </p:nvSpPr>
         <p:spPr>
           <a:xfrm>
-            <a:off x="6144768" y="1600200"/>
-            <a:ext cx="2560320" cy="4389120"/>
+            <a:off x="731520" y="3886200"/>
+            <a:ext cx="10728655" cy="1005840"/>
           </a:xfrm>
           <a:prstGeom prst="roundRect">
             <a:avLst/>
@@ -7611,7 +8759,7 @@
           <a:solidFill>
             <a:srgbClr val="F8FAFC"/>
           </a:solidFill>
-          <a:ln w="12700">
+          <a:ln>
             <a:solidFill>
               <a:srgbClr val="E2E8F0"/>
             </a:solidFill>
@@ -7641,20 +8789,20 @@
       </p:sp>
       <p:sp>
         <p:nvSpPr>
-          <p:cNvPr id="13" name="Rounded Rectangle 12"/>
+          <p:cNvPr id="13" name="Rectangle 12"/>
           <p:cNvSpPr/>
           <p:nvPr/>
         </p:nvSpPr>
         <p:spPr>
           <a:xfrm>
-            <a:off x="6144768" y="1600200"/>
-            <a:ext cx="2560320" cy="73152"/>
-          </a:xfrm>
-          <a:prstGeom prst="roundRect">
-            <a:avLst/>
-          </a:prstGeom>
-          <a:solidFill>
-            <a:srgbClr val="1B4332"/>
+            <a:off x="731520" y="3886200"/>
+            <a:ext cx="73152" cy="1005840"/>
+          </a:xfrm>
+          <a:prstGeom prst="rect">
+            <a:avLst/>
+          </a:prstGeom>
+          <a:solidFill>
+            <a:srgbClr val="D97706"/>
           </a:solidFill>
           <a:ln>
             <a:noFill/>
@@ -7690,8 +8838,8 @@
         </p:nvSpPr>
         <p:spPr>
           <a:xfrm>
-            <a:off x="6364224" y="1819656"/>
-            <a:ext cx="2121408" cy="3950208"/>
+            <a:off x="960120" y="3959352"/>
+            <a:ext cx="10332720" cy="868680"/>
           </a:xfrm>
           <a:prstGeom prst="rect">
             <a:avLst/>
@@ -7705,62 +8853,29 @@
           <a:lstStyle/>
           <a:p>
             <a:pPr>
-              <a:spcAft>
-                <a:spcPts val="800"/>
-              </a:spcAft>
-              <a:defRPr sz="1350" b="1">
-                <a:solidFill>
-                  <a:srgbClr val="1B4332"/>
-                </a:solidFill>
-              </a:defRPr>
-            </a:pPr>
-            <a:r>
-              <a:t>Step 3: Auditor Decisions</a:t>
-            </a:r>
-          </a:p>
-          <a:p>
-            <a:pPr>
-              <a:spcAft>
-                <a:spcPts val="400"/>
-              </a:spcAft>
-              <a:defRPr sz="1100">
+              <a:defRPr sz="1250" b="1">
+                <a:solidFill>
+                  <a:srgbClr val="D97706"/>
+                </a:solidFill>
+              </a:defRPr>
+            </a:pPr>
+            <a:r>
+              <a:t>#3. Earnings Quality Divergence — Subsidiary III  [MEDIUM]  •  Status: Under Auditor Inquiry</a:t>
+            </a:r>
+          </a:p>
+          <a:p>
+            <a:pPr>
+              <a:spcBef>
+                <a:spcPts val="300"/>
+              </a:spcBef>
+              <a:defRPr sz="1050">
                 <a:solidFill>
                   <a:srgbClr val="1E293B"/>
                 </a:solidFill>
               </a:defRPr>
             </a:pPr>
             <a:r>
-              <a:t>• Auditor selects status: Clarify / Audit Finding / Approved.</a:t>
-            </a:r>
-          </a:p>
-          <a:p>
-            <a:pPr>
-              <a:spcAft>
-                <a:spcPts val="400"/>
-              </a:spcAft>
-              <a:defRPr sz="1100">
-                <a:solidFill>
-                  <a:srgbClr val="1E293B"/>
-                </a:solidFill>
-              </a:defRPr>
-            </a:pPr>
-            <a:r>
-              <a:t>• Input field records auditor remarks &amp; requested documentation.</a:t>
-            </a:r>
-          </a:p>
-          <a:p>
-            <a:pPr>
-              <a:spcAft>
-                <a:spcPts val="400"/>
-              </a:spcAft>
-              <a:defRPr sz="1100">
-                <a:solidFill>
-                  <a:srgbClr val="1E293B"/>
-                </a:solidFill>
-              </a:defRPr>
-            </a:pPr>
-            <a:r>
-              <a:t>• One-click 'Request Clarification' logs notice to subsidiary.</a:t>
+              <a:t>Quantified Delta: Revenue grew +3.0% YoY while Net Income fell -6.1%   |   Audit Impact: Operating margin compression from unvetted overhead and administrative expense spikes.</a:t>
             </a:r>
           </a:p>
         </p:txBody>
@@ -7773,8 +8888,8 @@
         </p:nvSpPr>
         <p:spPr>
           <a:xfrm>
-            <a:off x="8851392" y="1600200"/>
-            <a:ext cx="2560320" cy="4389120"/>
+            <a:off x="731520" y="5029200"/>
+            <a:ext cx="10728655" cy="1005840"/>
           </a:xfrm>
           <a:prstGeom prst="roundRect">
             <a:avLst/>
@@ -7782,7 +8897,7 @@
           <a:solidFill>
             <a:srgbClr val="F8FAFC"/>
           </a:solidFill>
-          <a:ln w="12700">
+          <a:ln>
             <a:solidFill>
               <a:srgbClr val="E2E8F0"/>
             </a:solidFill>
@@ -7812,20 +8927,20 @@
       </p:sp>
       <p:sp>
         <p:nvSpPr>
-          <p:cNvPr id="16" name="Rounded Rectangle 15"/>
+          <p:cNvPr id="16" name="Rectangle 15"/>
           <p:cNvSpPr/>
           <p:nvPr/>
         </p:nvSpPr>
         <p:spPr>
           <a:xfrm>
-            <a:off x="8851392" y="1600200"/>
-            <a:ext cx="2560320" cy="73152"/>
-          </a:xfrm>
-          <a:prstGeom prst="roundRect">
-            <a:avLst/>
-          </a:prstGeom>
-          <a:solidFill>
-            <a:srgbClr val="0284C7"/>
+            <a:off x="731520" y="5029200"/>
+            <a:ext cx="73152" cy="1005840"/>
+          </a:xfrm>
+          <a:prstGeom prst="rect">
+            <a:avLst/>
+          </a:prstGeom>
+          <a:solidFill>
+            <a:srgbClr val="0D9488"/>
           </a:solidFill>
           <a:ln>
             <a:noFill/>
@@ -7861,8 +8976,8 @@
         </p:nvSpPr>
         <p:spPr>
           <a:xfrm>
-            <a:off x="9070848" y="1819656"/>
-            <a:ext cx="2121408" cy="3950208"/>
+            <a:off x="960120" y="5102352"/>
+            <a:ext cx="10332720" cy="868680"/>
           </a:xfrm>
           <a:prstGeom prst="rect">
             <a:avLst/>
@@ -7876,62 +8991,29 @@
           <a:lstStyle/>
           <a:p>
             <a:pPr>
-              <a:spcAft>
-                <a:spcPts val="800"/>
-              </a:spcAft>
-              <a:defRPr sz="1350" b="1">
-                <a:solidFill>
-                  <a:srgbClr val="0284C7"/>
-                </a:solidFill>
-              </a:defRPr>
-            </a:pPr>
-            <a:r>
-              <a:t>Step 4: Formal Sign-off</a:t>
-            </a:r>
-          </a:p>
-          <a:p>
-            <a:pPr>
-              <a:spcAft>
-                <a:spcPts val="400"/>
-              </a:spcAft>
-              <a:defRPr sz="1100">
+              <a:defRPr sz="1250" b="1">
+                <a:solidFill>
+                  <a:srgbClr val="0D9488"/>
+                </a:solidFill>
+              </a:defRPr>
+            </a:pPr>
+            <a:r>
+              <a:t>#4. Net Margin Expansion Shift — Subsidiary IV  [MODERATE]  •  Status: Justified / Approved</a:t>
+            </a:r>
+          </a:p>
+          <a:p>
+            <a:pPr>
+              <a:spcBef>
+                <a:spcPts val="300"/>
+              </a:spcBef>
+              <a:defRPr sz="1050">
                 <a:solidFill>
                   <a:srgbClr val="1E293B"/>
                 </a:solidFill>
               </a:defRPr>
             </a:pPr>
             <a:r>
-              <a:t>• Real-time tracking: X of Y anomalies reviewed.</a:t>
-            </a:r>
-          </a:p>
-          <a:p>
-            <a:pPr>
-              <a:spcAft>
-                <a:spcPts val="400"/>
-              </a:spcAft>
-              <a:defRPr sz="1100">
-                <a:solidFill>
-                  <a:srgbClr val="1E293B"/>
-                </a:solidFill>
-              </a:defRPr>
-            </a:pPr>
-            <a:r>
-              <a:t>• Formal sign-off locks workpaper with timestamp.</a:t>
-            </a:r>
-          </a:p>
-          <a:p>
-            <a:pPr>
-              <a:spcAft>
-                <a:spcPts val="400"/>
-              </a:spcAft>
-              <a:defRPr sz="1100">
-                <a:solidFill>
-                  <a:srgbClr val="1E293B"/>
-                </a:solidFill>
-              </a:defRPr>
-            </a:pPr>
-            <a:r>
-              <a:t>• One-click clean print to PDF ready for the Audit Committee.</a:t>
+              <a:t>Quantified Delta: Profit margin jumped from 7.2% to 10.8% (+3.6 pp)   |   Audit Impact: Verifying if expansion is operational or driven by non-recurring one-off capital gains.</a:t>
             </a:r>
           </a:p>
         </p:txBody>
@@ -8070,7 +9152,7 @@
               </a:defRPr>
             </a:pPr>
             <a:r>
-              <a:t>PRUDENTIAL RATIOS</a:t>
+              <a:t>QUANTITATIVE RULES</a:t>
             </a:r>
           </a:p>
         </p:txBody>
@@ -8105,7 +9187,7 @@
               </a:defRPr>
             </a:pPr>
             <a:r>
-              <a:t>Consolidated Financial Health vs. Sectoral Benchmarks</a:t>
+              <a:t>Forensic Anomaly Detection Engine: Vectors &amp; Thresholds</a:t>
             </a:r>
           </a:p>
         </p:txBody>
@@ -8119,7 +9201,7 @@
         <p:spPr>
           <a:xfrm>
             <a:off x="731520" y="1600200"/>
-            <a:ext cx="3328416" cy="4389120"/>
+            <a:ext cx="10728655" cy="1005840"/>
           </a:xfrm>
           <a:prstGeom prst="roundRect">
             <a:avLst/>
@@ -8157,20 +9239,20 @@
       </p:sp>
       <p:sp>
         <p:nvSpPr>
-          <p:cNvPr id="7" name="Rounded Rectangle 6"/>
+          <p:cNvPr id="7" name="Rectangle 6"/>
           <p:cNvSpPr/>
           <p:nvPr/>
         </p:nvSpPr>
         <p:spPr>
           <a:xfrm>
             <a:off x="731520" y="1600200"/>
-            <a:ext cx="3328416" cy="73152"/>
-          </a:xfrm>
-          <a:prstGeom prst="roundRect">
-            <a:avLst/>
-          </a:prstGeom>
-          <a:solidFill>
-            <a:srgbClr val="0D9488"/>
+            <a:ext cx="73152" cy="1005840"/>
+          </a:xfrm>
+          <a:prstGeom prst="rect">
+            <a:avLst/>
+          </a:prstGeom>
+          <a:solidFill>
+            <a:srgbClr val="E11D48"/>
           </a:solidFill>
           <a:ln>
             <a:noFill/>
@@ -8206,8 +9288,8 @@
         </p:nvSpPr>
         <p:spPr>
           <a:xfrm>
-            <a:off x="950976" y="1819656"/>
-            <a:ext cx="2889504" cy="3931920"/>
+            <a:off x="960120" y="1709928"/>
+            <a:ext cx="10332720" cy="786384"/>
           </a:xfrm>
           <a:prstGeom prst="rect">
             <a:avLst/>
@@ -8221,81 +9303,29 @@
           <a:lstStyle/>
           <a:p>
             <a:pPr>
-              <a:spcAft>
-                <a:spcPts val="600"/>
-              </a:spcAft>
-              <a:defRPr sz="1400" b="1">
-                <a:solidFill>
-                  <a:srgbClr val="0F172A"/>
-                </a:solidFill>
-              </a:defRPr>
-            </a:pPr>
-            <a:r>
-              <a:t>Solvency (DER)</a:t>
-            </a:r>
-          </a:p>
-          <a:p>
-            <a:pPr>
-              <a:spcAft>
-                <a:spcPts val="600"/>
-              </a:spcAft>
-              <a:defRPr sz="1100" b="1">
+              <a:defRPr sz="1350" b="1">
+                <a:solidFill>
+                  <a:srgbClr val="E11D48"/>
+                </a:solidFill>
+              </a:defRPr>
+            </a:pPr>
+            <a:r>
+              <a:t>1. NCI Profit Allocation Disparity  [CRITICAL]</a:t>
+            </a:r>
+          </a:p>
+          <a:p>
+            <a:pPr>
+              <a:spcBef>
+                <a:spcPts val="300"/>
+              </a:spcBef>
+              <a:defRPr sz="1100">
                 <a:solidFill>
                   <a:srgbClr val="1E293B"/>
                 </a:solidFill>
               </a:defRPr>
             </a:pPr>
             <a:r>
-              <a:t>Consolidated: 0.96x</a:t>
-            </a:r>
-            <a:br/>
-            <a:r>
-              <a:t>Regulatory Ceiling: Max 5.0x</a:t>
-            </a:r>
-          </a:p>
-          <a:p>
-            <a:pPr>
-              <a:spcAft>
-                <a:spcPts val="1000"/>
-              </a:spcAft>
-              <a:defRPr sz="1000" b="1">
-                <a:solidFill>
-                  <a:srgbClr val="0D9488"/>
-                </a:solidFill>
-              </a:defRPr>
-            </a:pPr>
-            <a:r>
-              <a:t>STATUS: HIGHLY CONSERVATIVE</a:t>
-            </a:r>
-          </a:p>
-          <a:p>
-            <a:pPr>
-              <a:spcAft>
-                <a:spcPts val="400"/>
-              </a:spcAft>
-              <a:defRPr sz="1100">
-                <a:solidFill>
-                  <a:srgbClr val="1E293B"/>
-                </a:solidFill>
-              </a:defRPr>
-            </a:pPr>
-            <a:r>
-              <a:t>• Capital structure provides ample liquidity buffer for operational growth.</a:t>
-            </a:r>
-          </a:p>
-          <a:p>
-            <a:pPr>
-              <a:spcAft>
-                <a:spcPts val="400"/>
-              </a:spcAft>
-              <a:defRPr sz="1100">
-                <a:solidFill>
-                  <a:srgbClr val="1E293B"/>
-                </a:solidFill>
-              </a:defRPr>
-            </a:pPr>
-            <a:r>
-              <a:t>• Well below regulatory leverage thresholds for financial institutions.</a:t>
+              <a:t>Formula: |Reported NCI - Computed NCI| &gt; 8%   •   Audit Objective: Prevents parent income distortion and safeguards minority shareholder dividend equity under IFRS 10 / PSAK 65.</a:t>
             </a:r>
           </a:p>
         </p:txBody>
@@ -8308,8 +9338,8 @@
         </p:nvSpPr>
         <p:spPr>
           <a:xfrm>
-            <a:off x="4416552" y="1600200"/>
-            <a:ext cx="3328416" cy="4389120"/>
+            <a:off x="731520" y="2743200"/>
+            <a:ext cx="10728655" cy="1005840"/>
           </a:xfrm>
           <a:prstGeom prst="roundRect">
             <a:avLst/>
@@ -8347,20 +9377,20 @@
       </p:sp>
       <p:sp>
         <p:nvSpPr>
-          <p:cNvPr id="10" name="Rounded Rectangle 9"/>
+          <p:cNvPr id="10" name="Rectangle 9"/>
           <p:cNvSpPr/>
           <p:nvPr/>
         </p:nvSpPr>
         <p:spPr>
           <a:xfrm>
-            <a:off x="4416552" y="1600200"/>
-            <a:ext cx="3328416" cy="73152"/>
-          </a:xfrm>
-          <a:prstGeom prst="roundRect">
-            <a:avLst/>
-          </a:prstGeom>
-          <a:solidFill>
-            <a:srgbClr val="0D9488"/>
+            <a:off x="731520" y="2743200"/>
+            <a:ext cx="73152" cy="1005840"/>
+          </a:xfrm>
+          <a:prstGeom prst="rect">
+            <a:avLst/>
+          </a:prstGeom>
+          <a:solidFill>
+            <a:srgbClr val="E11D48"/>
           </a:solidFill>
           <a:ln>
             <a:noFill/>
@@ -8396,8 +9426,8 @@
         </p:nvSpPr>
         <p:spPr>
           <a:xfrm>
-            <a:off x="4636008" y="1819656"/>
-            <a:ext cx="2889504" cy="3931920"/>
+            <a:off x="960120" y="2852928"/>
+            <a:ext cx="10332720" cy="786384"/>
           </a:xfrm>
           <a:prstGeom prst="rect">
             <a:avLst/>
@@ -8411,81 +9441,29 @@
           <a:lstStyle/>
           <a:p>
             <a:pPr>
-              <a:spcAft>
-                <a:spcPts val="600"/>
-              </a:spcAft>
-              <a:defRPr sz="1400" b="1">
-                <a:solidFill>
-                  <a:srgbClr val="0F172A"/>
-                </a:solidFill>
-              </a:defRPr>
-            </a:pPr>
-            <a:r>
-              <a:t>Profitability (ROA)</a:t>
-            </a:r>
-          </a:p>
-          <a:p>
-            <a:pPr>
-              <a:spcAft>
-                <a:spcPts val="600"/>
-              </a:spcAft>
-              <a:defRPr sz="1100" b="1">
+              <a:defRPr sz="1350" b="1">
+                <a:solidFill>
+                  <a:srgbClr val="E11D48"/>
+                </a:solidFill>
+              </a:defRPr>
+            </a:pPr>
+            <a:r>
+              <a:t>2. Related-Party Debt Acceleration  [CRITICAL]</a:t>
+            </a:r>
+          </a:p>
+          <a:p>
+            <a:pPr>
+              <a:spcBef>
+                <a:spcPts val="300"/>
+              </a:spcBef>
+              <a:defRPr sz="1100">
                 <a:solidFill>
                   <a:srgbClr val="1E293B"/>
                 </a:solidFill>
               </a:defRPr>
             </a:pPr>
             <a:r>
-              <a:t>Consolidated: 5.4%</a:t>
-            </a:r>
-            <a:br/>
-            <a:r>
-              <a:t>Industry Average: 3.5% - 5.2%</a:t>
-            </a:r>
-          </a:p>
-          <a:p>
-            <a:pPr>
-              <a:spcAft>
-                <a:spcPts val="1000"/>
-              </a:spcAft>
-              <a:defRPr sz="1000" b="1">
-                <a:solidFill>
-                  <a:srgbClr val="0D9488"/>
-                </a:solidFill>
-              </a:defRPr>
-            </a:pPr>
-            <a:r>
-              <a:t>STATUS: OUTPERFORMING</a:t>
-            </a:r>
-          </a:p>
-          <a:p>
-            <a:pPr>
-              <a:spcAft>
-                <a:spcPts val="400"/>
-              </a:spcAft>
-              <a:defRPr sz="1100">
-                <a:solidFill>
-                  <a:srgbClr val="1E293B"/>
-                </a:solidFill>
-              </a:defRPr>
-            </a:pPr>
-            <a:r>
-              <a:t>• Group asset return sits in the upper quartile of microfinance peers.</a:t>
-            </a:r>
-          </a:p>
-          <a:p>
-            <a:pPr>
-              <a:spcAft>
-                <a:spcPts val="400"/>
-              </a:spcAft>
-              <a:defRPr sz="1100">
-                <a:solidFill>
-                  <a:srgbClr val="1E293B"/>
-                </a:solidFill>
-              </a:defRPr>
-            </a:pPr>
-            <a:r>
-              <a:t>• Consolidated Net Income expanded +14.2% YoY ($325M vs $284.7M).</a:t>
+              <a:t>Formula: ΔRP Receivables - ΔRevenue &gt; 30%   •   Audit Objective: Detects liquidity outflows into affiliated entities and halts hidden internal non-performing debt under IAS 24 / PSAK 7.</a:t>
             </a:r>
           </a:p>
         </p:txBody>
@@ -8498,8 +9476,8 @@
         </p:nvSpPr>
         <p:spPr>
           <a:xfrm>
-            <a:off x="8101584" y="1600200"/>
-            <a:ext cx="3328416" cy="4389120"/>
+            <a:off x="731520" y="3886200"/>
+            <a:ext cx="10728655" cy="1005840"/>
           </a:xfrm>
           <a:prstGeom prst="roundRect">
             <a:avLst/>
@@ -8537,16 +9515,16 @@
       </p:sp>
       <p:sp>
         <p:nvSpPr>
-          <p:cNvPr id="13" name="Rounded Rectangle 12"/>
+          <p:cNvPr id="13" name="Rectangle 12"/>
           <p:cNvSpPr/>
           <p:nvPr/>
         </p:nvSpPr>
         <p:spPr>
           <a:xfrm>
-            <a:off x="8101584" y="1600200"/>
-            <a:ext cx="3328416" cy="73152"/>
-          </a:xfrm>
-          <a:prstGeom prst="roundRect">
+            <a:off x="731520" y="3886200"/>
+            <a:ext cx="73152" cy="1005840"/>
+          </a:xfrm>
+          <a:prstGeom prst="rect">
             <a:avLst/>
           </a:prstGeom>
           <a:solidFill>
@@ -8586,8 +9564,8 @@
         </p:nvSpPr>
         <p:spPr>
           <a:xfrm>
-            <a:off x="8321040" y="1819656"/>
-            <a:ext cx="2889504" cy="3931920"/>
+            <a:off x="960120" y="3995928"/>
+            <a:ext cx="10332720" cy="786384"/>
           </a:xfrm>
           <a:prstGeom prst="rect">
             <a:avLst/>
@@ -8601,58 +9579,159 @@
           <a:lstStyle/>
           <a:p>
             <a:pPr>
-              <a:spcAft>
-                <a:spcPts val="600"/>
-              </a:spcAft>
-              <a:defRPr sz="1400" b="1">
-                <a:solidFill>
-                  <a:srgbClr val="0F172A"/>
-                </a:solidFill>
-              </a:defRPr>
-            </a:pPr>
-            <a:r>
-              <a:t>Affiliated Debt (RP)</a:t>
-            </a:r>
-          </a:p>
-          <a:p>
-            <a:pPr>
-              <a:spcAft>
-                <a:spcPts val="600"/>
-              </a:spcAft>
-              <a:defRPr sz="1100" b="1">
+              <a:defRPr sz="1350" b="1">
+                <a:solidFill>
+                  <a:srgbClr val="D97706"/>
+                </a:solidFill>
+              </a:defRPr>
+            </a:pPr>
+            <a:r>
+              <a:t>3. Sudden Leverage / DER Escalation  [MEDIUM]</a:t>
+            </a:r>
+          </a:p>
+          <a:p>
+            <a:pPr>
+              <a:spcBef>
+                <a:spcPts val="300"/>
+              </a:spcBef>
+              <a:defRPr sz="1100">
                 <a:solidFill>
                   <a:srgbClr val="1E293B"/>
                 </a:solidFill>
               </a:defRPr>
             </a:pPr>
             <a:r>
-              <a:t>Total RP Receivables: $241M</a:t>
-            </a:r>
-            <a:br/>
-            <a:r>
-              <a:t>Share of Total Assets: 4.3%</a:t>
-            </a:r>
-          </a:p>
-          <a:p>
-            <a:pPr>
-              <a:spcAft>
-                <a:spcPts val="1000"/>
-              </a:spcAft>
-              <a:defRPr sz="1000" b="1">
-                <a:solidFill>
-                  <a:srgbClr val="D97706"/>
-                </a:solidFill>
-              </a:defRPr>
-            </a:pPr>
-            <a:r>
-              <a:t>STATUS: CONCENTRATION WATCH</a:t>
-            </a:r>
-          </a:p>
-          <a:p>
-            <a:pPr>
-              <a:spcAft>
-                <a:spcPts val="400"/>
-              </a:spcAft>
+              <a:t>Formula: DER CY / DER PY - 1 &gt; 18%   •   Audit Objective: Monitors subsidiary debt growth before debt-to-equity ratios breach bank debt covenants or regulatory limits.</a:t>
+            </a:r>
+          </a:p>
+        </p:txBody>
+      </p:sp>
+      <p:sp>
+        <p:nvSpPr>
+          <p:cNvPr id="15" name="Rounded Rectangle 14"/>
+          <p:cNvSpPr/>
+          <p:nvPr/>
+        </p:nvSpPr>
+        <p:spPr>
+          <a:xfrm>
+            <a:off x="731520" y="5029200"/>
+            <a:ext cx="10728655" cy="1005840"/>
+          </a:xfrm>
+          <a:prstGeom prst="roundRect">
+            <a:avLst/>
+          </a:prstGeom>
+          <a:solidFill>
+            <a:srgbClr val="F8FAFC"/>
+          </a:solidFill>
+          <a:ln>
+            <a:solidFill>
+              <a:srgbClr val="E2E8F0"/>
+            </a:solidFill>
+          </a:ln>
+        </p:spPr>
+        <p:style>
+          <a:lnRef idx="1">
+            <a:schemeClr val="accent1"/>
+          </a:lnRef>
+          <a:fillRef idx="3">
+            <a:schemeClr val="accent1"/>
+          </a:fillRef>
+          <a:effectRef idx="2">
+            <a:schemeClr val="accent1"/>
+          </a:effectRef>
+          <a:fontRef idx="minor">
+            <a:schemeClr val="lt1"/>
+          </a:fontRef>
+        </p:style>
+        <p:txBody>
+          <a:bodyPr rtlCol="0" anchor="ctr"/>
+          <a:lstStyle/>
+          <a:p>
+            <a:pPr algn="ctr"/>
+          </a:p>
+        </p:txBody>
+      </p:sp>
+      <p:sp>
+        <p:nvSpPr>
+          <p:cNvPr id="16" name="Rectangle 15"/>
+          <p:cNvSpPr/>
+          <p:nvPr/>
+        </p:nvSpPr>
+        <p:spPr>
+          <a:xfrm>
+            <a:off x="731520" y="5029200"/>
+            <a:ext cx="73152" cy="1005840"/>
+          </a:xfrm>
+          <a:prstGeom prst="rect">
+            <a:avLst/>
+          </a:prstGeom>
+          <a:solidFill>
+            <a:srgbClr val="0D9488"/>
+          </a:solidFill>
+          <a:ln>
+            <a:noFill/>
+          </a:ln>
+        </p:spPr>
+        <p:style>
+          <a:lnRef idx="1">
+            <a:schemeClr val="accent1"/>
+          </a:lnRef>
+          <a:fillRef idx="3">
+            <a:schemeClr val="accent1"/>
+          </a:fillRef>
+          <a:effectRef idx="2">
+            <a:schemeClr val="accent1"/>
+          </a:effectRef>
+          <a:fontRef idx="minor">
+            <a:schemeClr val="lt1"/>
+          </a:fontRef>
+        </p:style>
+        <p:txBody>
+          <a:bodyPr rtlCol="0" anchor="ctr"/>
+          <a:lstStyle/>
+          <a:p>
+            <a:pPr algn="ctr"/>
+          </a:p>
+        </p:txBody>
+      </p:sp>
+      <p:sp>
+        <p:nvSpPr>
+          <p:cNvPr id="17" name="TextBox 16"/>
+          <p:cNvSpPr txBox="1"/>
+          <p:nvPr/>
+        </p:nvSpPr>
+        <p:spPr>
+          <a:xfrm>
+            <a:off x="960120" y="5138928"/>
+            <a:ext cx="10332720" cy="786384"/>
+          </a:xfrm>
+          <a:prstGeom prst="rect">
+            <a:avLst/>
+          </a:prstGeom>
+          <a:noFill/>
+        </p:spPr>
+        <p:txBody>
+          <a:bodyPr wrap="square">
+            <a:spAutoFit/>
+          </a:bodyPr>
+          <a:lstStyle/>
+          <a:p>
+            <a:pPr>
+              <a:defRPr sz="1350" b="1">
+                <a:solidFill>
+                  <a:srgbClr val="0D9488"/>
+                </a:solidFill>
+              </a:defRPr>
+            </a:pPr>
+            <a:r>
+              <a:t>4. Profit Margin Distortion  [MODERATE]</a:t>
+            </a:r>
+          </a:p>
+          <a:p>
+            <a:pPr>
+              <a:spcBef>
+                <a:spcPts val="300"/>
+              </a:spcBef>
               <a:defRPr sz="1100">
                 <a:solidFill>
                   <a:srgbClr val="1E293B"/>
@@ -8660,22 +9739,7 @@
               </a:defRPr>
             </a:pPr>
             <a:r>
-              <a:t>• Aggregate exposure is proportional to balance sheet scale.</a:t>
-            </a:r>
-          </a:p>
-          <a:p>
-            <a:pPr>
-              <a:spcAft>
-                <a:spcPts val="400"/>
-              </a:spcAft>
-              <a:defRPr sz="1100">
-                <a:solidFill>
-                  <a:srgbClr val="1E293B"/>
-                </a:solidFill>
-              </a:defRPr>
-            </a:pPr>
-            <a:r>
-              <a:t>• However, concentration at Subsidiary II ($88M) warrants tight monitoring.</a:t>
+              <a:t>Formula: |Margin CY - Margin PY| ≥ 3.5 pp   •   Audit Objective: Verifies whether margin expansion/compression stems from genuine operations or one-off artificial transactions.</a:t>
             </a:r>
           </a:p>
         </p:txBody>
@@ -8814,7 +9878,7 @@
               </a:defRPr>
             </a:pPr>
             <a:r>
-              <a:t>VALUE DELIVERY</a:t>
+              <a:t>PRUDENTIAL RATIOS</a:t>
             </a:r>
           </a:p>
         </p:txBody>
@@ -8849,7 +9913,7 @@
               </a:defRPr>
             </a:pPr>
             <a:r>
-              <a:t>Stakeholder Expectation Alignment Matrix</a:t>
+              <a:t>Consolidated Financial Health vs. Sectoral Benchmarks</a:t>
             </a:r>
           </a:p>
         </p:txBody>
@@ -8862,8 +9926,8 @@
         </p:nvSpPr>
         <p:spPr>
           <a:xfrm>
-            <a:off x="731520" y="1554480"/>
-            <a:ext cx="10728655" cy="822960"/>
+            <a:off x="731520" y="1600200"/>
+            <a:ext cx="3328416" cy="4389120"/>
           </a:xfrm>
           <a:prstGeom prst="roundRect">
             <a:avLst/>
@@ -8901,20 +9965,20 @@
       </p:sp>
       <p:sp>
         <p:nvSpPr>
-          <p:cNvPr id="7" name="Rectangle 6"/>
+          <p:cNvPr id="7" name="Rounded Rectangle 6"/>
           <p:cNvSpPr/>
           <p:nvPr/>
         </p:nvSpPr>
         <p:spPr>
           <a:xfrm>
-            <a:off x="731520" y="1554480"/>
-            <a:ext cx="54864" cy="822960"/>
-          </a:xfrm>
-          <a:prstGeom prst="rect">
-            <a:avLst/>
-          </a:prstGeom>
-          <a:solidFill>
-            <a:srgbClr val="1B4332"/>
+            <a:off x="731520" y="1600200"/>
+            <a:ext cx="3328416" cy="73152"/>
+          </a:xfrm>
+          <a:prstGeom prst="roundRect">
+            <a:avLst/>
+          </a:prstGeom>
+          <a:solidFill>
+            <a:srgbClr val="0D9488"/>
           </a:solidFill>
           <a:ln>
             <a:noFill/>
@@ -8950,8 +10014,8 @@
         </p:nvSpPr>
         <p:spPr>
           <a:xfrm>
-            <a:off x="914400" y="1627632"/>
-            <a:ext cx="10332720" cy="685800"/>
+            <a:off x="950976" y="1819656"/>
+            <a:ext cx="2889504" cy="3931920"/>
           </a:xfrm>
           <a:prstGeom prst="rect">
             <a:avLst/>
@@ -8965,26 +10029,81 @@
           <a:lstStyle/>
           <a:p>
             <a:pPr>
-              <a:defRPr sz="1050" b="1">
-                <a:solidFill>
-                  <a:srgbClr val="B48214"/>
-                </a:solidFill>
-              </a:defRPr>
-            </a:pPr>
-            <a:r>
-              <a:t>AUDIT COMMITTEE / BOARD OF SUPERVISORS</a:t>
-            </a:r>
-          </a:p>
-          <a:p>
-            <a:pPr>
-              <a:defRPr sz="1050">
+              <a:spcAft>
+                <a:spcPts val="600"/>
+              </a:spcAft>
+              <a:defRPr sz="1400" b="1">
+                <a:solidFill>
+                  <a:srgbClr val="0F172A"/>
+                </a:solidFill>
+              </a:defRPr>
+            </a:pPr>
+            <a:r>
+              <a:t>Solvency (DER)</a:t>
+            </a:r>
+          </a:p>
+          <a:p>
+            <a:pPr>
+              <a:spcAft>
+                <a:spcPts val="600"/>
+              </a:spcAft>
+              <a:defRPr sz="1100" b="1">
                 <a:solidFill>
                   <a:srgbClr val="1E293B"/>
                 </a:solidFill>
               </a:defRPr>
             </a:pPr>
             <a:r>
-              <a:t>Expectation: "Prevent material misstatements &amp; NCI leakage prior to external audits."  ➔  Delivery: Automated IFRS 10 rule engine verifies profit distribution &amp; flags critical anomalies instantly.</a:t>
+              <a:t>Consolidated: 0.96x</a:t>
+            </a:r>
+            <a:br/>
+            <a:r>
+              <a:t>Regulatory Ceiling: Max 5.0x</a:t>
+            </a:r>
+          </a:p>
+          <a:p>
+            <a:pPr>
+              <a:spcAft>
+                <a:spcPts val="1000"/>
+              </a:spcAft>
+              <a:defRPr sz="1000" b="1">
+                <a:solidFill>
+                  <a:srgbClr val="0D9488"/>
+                </a:solidFill>
+              </a:defRPr>
+            </a:pPr>
+            <a:r>
+              <a:t>STATUS: HIGHLY CONSERVATIVE</a:t>
+            </a:r>
+          </a:p>
+          <a:p>
+            <a:pPr>
+              <a:spcAft>
+                <a:spcPts val="400"/>
+              </a:spcAft>
+              <a:defRPr sz="1100">
+                <a:solidFill>
+                  <a:srgbClr val="1E293B"/>
+                </a:solidFill>
+              </a:defRPr>
+            </a:pPr>
+            <a:r>
+              <a:t>• Capital structure provides ample liquidity buffer for operational growth.</a:t>
+            </a:r>
+          </a:p>
+          <a:p>
+            <a:pPr>
+              <a:spcAft>
+                <a:spcPts val="400"/>
+              </a:spcAft>
+              <a:defRPr sz="1100">
+                <a:solidFill>
+                  <a:srgbClr val="1E293B"/>
+                </a:solidFill>
+              </a:defRPr>
+            </a:pPr>
+            <a:r>
+              <a:t>• Well below regulatory leverage thresholds for financial institutions.</a:t>
             </a:r>
           </a:p>
         </p:txBody>
@@ -8997,8 +10116,8 @@
         </p:nvSpPr>
         <p:spPr>
           <a:xfrm>
-            <a:off x="731520" y="2468880"/>
-            <a:ext cx="10728655" cy="822960"/>
+            <a:off x="4416552" y="1600200"/>
+            <a:ext cx="3328416" cy="4389120"/>
           </a:xfrm>
           <a:prstGeom prst="roundRect">
             <a:avLst/>
@@ -9036,20 +10155,20 @@
       </p:sp>
       <p:sp>
         <p:nvSpPr>
-          <p:cNvPr id="10" name="Rectangle 9"/>
+          <p:cNvPr id="10" name="Rounded Rectangle 9"/>
           <p:cNvSpPr/>
           <p:nvPr/>
         </p:nvSpPr>
         <p:spPr>
           <a:xfrm>
-            <a:off x="731520" y="2468880"/>
-            <a:ext cx="54864" cy="822960"/>
-          </a:xfrm>
-          <a:prstGeom prst="rect">
-            <a:avLst/>
-          </a:prstGeom>
-          <a:solidFill>
-            <a:srgbClr val="1B4332"/>
+            <a:off x="4416552" y="1600200"/>
+            <a:ext cx="3328416" cy="73152"/>
+          </a:xfrm>
+          <a:prstGeom prst="roundRect">
+            <a:avLst/>
+          </a:prstGeom>
+          <a:solidFill>
+            <a:srgbClr val="0D9488"/>
           </a:solidFill>
           <a:ln>
             <a:noFill/>
@@ -9085,8 +10204,8 @@
         </p:nvSpPr>
         <p:spPr>
           <a:xfrm>
-            <a:off x="914400" y="2542032"/>
-            <a:ext cx="10332720" cy="685800"/>
+            <a:off x="4636008" y="1819656"/>
+            <a:ext cx="2889504" cy="3931920"/>
           </a:xfrm>
           <a:prstGeom prst="rect">
             <a:avLst/>
@@ -9100,26 +10219,81 @@
           <a:lstStyle/>
           <a:p>
             <a:pPr>
-              <a:defRPr sz="1050" b="1">
-                <a:solidFill>
-                  <a:srgbClr val="B48214"/>
-                </a:solidFill>
-              </a:defRPr>
-            </a:pPr>
-            <a:r>
-              <a:t>GROUP CHIEF FINANCIAL OFFICER (CFO)</a:t>
-            </a:r>
-          </a:p>
-          <a:p>
-            <a:pPr>
-              <a:defRPr sz="1050">
+              <a:spcAft>
+                <a:spcPts val="600"/>
+              </a:spcAft>
+              <a:defRPr sz="1400" b="1">
+                <a:solidFill>
+                  <a:srgbClr val="0F172A"/>
+                </a:solidFill>
+              </a:defRPr>
+            </a:pPr>
+            <a:r>
+              <a:t>Profitability (ROA)</a:t>
+            </a:r>
+          </a:p>
+          <a:p>
+            <a:pPr>
+              <a:spcAft>
+                <a:spcPts val="600"/>
+              </a:spcAft>
+              <a:defRPr sz="1100" b="1">
                 <a:solidFill>
                   <a:srgbClr val="1E293B"/>
                 </a:solidFill>
               </a:defRPr>
             </a:pPr>
             <a:r>
-              <a:t>Expectation: "Accelerate group consolidation closing cycles with zero arithmetic risk."  ➔  Delivery: Dynamic KPI summaries, instant sensitivity simulations, and executive board-ready memos.</a:t>
+              <a:t>Consolidated: 5.4%</a:t>
+            </a:r>
+            <a:br/>
+            <a:r>
+              <a:t>Industry Average: 3.5% - 5.2%</a:t>
+            </a:r>
+          </a:p>
+          <a:p>
+            <a:pPr>
+              <a:spcAft>
+                <a:spcPts val="1000"/>
+              </a:spcAft>
+              <a:defRPr sz="1000" b="1">
+                <a:solidFill>
+                  <a:srgbClr val="0D9488"/>
+                </a:solidFill>
+              </a:defRPr>
+            </a:pPr>
+            <a:r>
+              <a:t>STATUS: OUTPERFORMING</a:t>
+            </a:r>
+          </a:p>
+          <a:p>
+            <a:pPr>
+              <a:spcAft>
+                <a:spcPts val="400"/>
+              </a:spcAft>
+              <a:defRPr sz="1100">
+                <a:solidFill>
+                  <a:srgbClr val="1E293B"/>
+                </a:solidFill>
+              </a:defRPr>
+            </a:pPr>
+            <a:r>
+              <a:t>• Group asset return sits in the upper quartile of microfinance peers.</a:t>
+            </a:r>
+          </a:p>
+          <a:p>
+            <a:pPr>
+              <a:spcAft>
+                <a:spcPts val="400"/>
+              </a:spcAft>
+              <a:defRPr sz="1100">
+                <a:solidFill>
+                  <a:srgbClr val="1E293B"/>
+                </a:solidFill>
+              </a:defRPr>
+            </a:pPr>
+            <a:r>
+              <a:t>• Consolidated Net Income expanded +14.2% YoY ($325M vs $284.7M).</a:t>
             </a:r>
           </a:p>
         </p:txBody>
@@ -9132,8 +10306,8 @@
         </p:nvSpPr>
         <p:spPr>
           <a:xfrm>
-            <a:off x="731520" y="3383280"/>
-            <a:ext cx="10728655" cy="822960"/>
+            <a:off x="8101584" y="1600200"/>
+            <a:ext cx="3328416" cy="4389120"/>
           </a:xfrm>
           <a:prstGeom prst="roundRect">
             <a:avLst/>
@@ -9171,20 +10345,20 @@
       </p:sp>
       <p:sp>
         <p:nvSpPr>
-          <p:cNvPr id="13" name="Rectangle 12"/>
+          <p:cNvPr id="13" name="Rounded Rectangle 12"/>
           <p:cNvSpPr/>
           <p:nvPr/>
         </p:nvSpPr>
         <p:spPr>
           <a:xfrm>
-            <a:off x="731520" y="3383280"/>
-            <a:ext cx="54864" cy="822960"/>
-          </a:xfrm>
-          <a:prstGeom prst="rect">
-            <a:avLst/>
-          </a:prstGeom>
-          <a:solidFill>
-            <a:srgbClr val="1B4332"/>
+            <a:off x="8101584" y="1600200"/>
+            <a:ext cx="3328416" cy="73152"/>
+          </a:xfrm>
+          <a:prstGeom prst="roundRect">
+            <a:avLst/>
+          </a:prstGeom>
+          <a:solidFill>
+            <a:srgbClr val="D97706"/>
           </a:solidFill>
           <a:ln>
             <a:noFill/>
@@ -9220,8 +10394,8 @@
         </p:nvSpPr>
         <p:spPr>
           <a:xfrm>
-            <a:off x="914400" y="3456432"/>
-            <a:ext cx="10332720" cy="685800"/>
+            <a:off x="8321040" y="1819656"/>
+            <a:ext cx="2889504" cy="3931920"/>
           </a:xfrm>
           <a:prstGeom prst="rect">
             <a:avLst/>
@@ -9235,296 +10409,81 @@
           <a:lstStyle/>
           <a:p>
             <a:pPr>
-              <a:defRPr sz="1050" b="1">
-                <a:solidFill>
-                  <a:srgbClr val="B48214"/>
-                </a:solidFill>
-              </a:defRPr>
-            </a:pPr>
-            <a:r>
-              <a:t>INTERNAL AUDIT LEADERSHIP</a:t>
-            </a:r>
-          </a:p>
-          <a:p>
-            <a:pPr>
-              <a:defRPr sz="1050">
+              <a:spcAft>
+                <a:spcPts val="600"/>
+              </a:spcAft>
+              <a:defRPr sz="1400" b="1">
+                <a:solidFill>
+                  <a:srgbClr val="0F172A"/>
+                </a:solidFill>
+              </a:defRPr>
+            </a:pPr>
+            <a:r>
+              <a:t>Affiliated Debt (RP)</a:t>
+            </a:r>
+          </a:p>
+          <a:p>
+            <a:pPr>
+              <a:spcAft>
+                <a:spcPts val="600"/>
+              </a:spcAft>
+              <a:defRPr sz="1100" b="1">
                 <a:solidFill>
                   <a:srgbClr val="1E293B"/>
                 </a:solidFill>
               </a:defRPr>
             </a:pPr>
             <a:r>
-              <a:t>Expectation: "Maintain structured electronic workpapers with traceable sign-offs."  ➔  Delivery: Actionable Review Workspace with item status toggles, auditor notes, and timestamped audit trails.</a:t>
-            </a:r>
-          </a:p>
-        </p:txBody>
-      </p:sp>
-      <p:sp>
-        <p:nvSpPr>
-          <p:cNvPr id="15" name="Rounded Rectangle 14"/>
-          <p:cNvSpPr/>
-          <p:nvPr/>
-        </p:nvSpPr>
-        <p:spPr>
-          <a:xfrm>
-            <a:off x="731520" y="4297680"/>
-            <a:ext cx="10728655" cy="822960"/>
-          </a:xfrm>
-          <a:prstGeom prst="roundRect">
-            <a:avLst/>
-          </a:prstGeom>
-          <a:solidFill>
-            <a:srgbClr val="F8FAFC"/>
-          </a:solidFill>
-          <a:ln>
-            <a:solidFill>
-              <a:srgbClr val="E2E8F0"/>
-            </a:solidFill>
-          </a:ln>
-        </p:spPr>
-        <p:style>
-          <a:lnRef idx="1">
-            <a:schemeClr val="accent1"/>
-          </a:lnRef>
-          <a:fillRef idx="3">
-            <a:schemeClr val="accent1"/>
-          </a:fillRef>
-          <a:effectRef idx="2">
-            <a:schemeClr val="accent1"/>
-          </a:effectRef>
-          <a:fontRef idx="minor">
-            <a:schemeClr val="lt1"/>
-          </a:fontRef>
-        </p:style>
-        <p:txBody>
-          <a:bodyPr rtlCol="0" anchor="ctr"/>
-          <a:lstStyle/>
-          <a:p>
-            <a:pPr algn="ctr"/>
-          </a:p>
-        </p:txBody>
-      </p:sp>
-      <p:sp>
-        <p:nvSpPr>
-          <p:cNvPr id="16" name="Rectangle 15"/>
-          <p:cNvSpPr/>
-          <p:nvPr/>
-        </p:nvSpPr>
-        <p:spPr>
-          <a:xfrm>
-            <a:off x="731520" y="4297680"/>
-            <a:ext cx="54864" cy="822960"/>
-          </a:xfrm>
-          <a:prstGeom prst="rect">
-            <a:avLst/>
-          </a:prstGeom>
-          <a:solidFill>
-            <a:srgbClr val="1B4332"/>
-          </a:solidFill>
-          <a:ln>
-            <a:noFill/>
-          </a:ln>
-        </p:spPr>
-        <p:style>
-          <a:lnRef idx="1">
-            <a:schemeClr val="accent1"/>
-          </a:lnRef>
-          <a:fillRef idx="3">
-            <a:schemeClr val="accent1"/>
-          </a:fillRef>
-          <a:effectRef idx="2">
-            <a:schemeClr val="accent1"/>
-          </a:effectRef>
-          <a:fontRef idx="minor">
-            <a:schemeClr val="lt1"/>
-          </a:fontRef>
-        </p:style>
-        <p:txBody>
-          <a:bodyPr rtlCol="0" anchor="ctr"/>
-          <a:lstStyle/>
-          <a:p>
-            <a:pPr algn="ctr"/>
-          </a:p>
-        </p:txBody>
-      </p:sp>
-      <p:sp>
-        <p:nvSpPr>
-          <p:cNvPr id="17" name="TextBox 16"/>
-          <p:cNvSpPr txBox="1"/>
-          <p:nvPr/>
-        </p:nvSpPr>
-        <p:spPr>
-          <a:xfrm>
-            <a:off x="914400" y="4370832"/>
-            <a:ext cx="10332720" cy="685800"/>
-          </a:xfrm>
-          <a:prstGeom prst="rect">
-            <a:avLst/>
-          </a:prstGeom>
-          <a:noFill/>
-        </p:spPr>
-        <p:txBody>
-          <a:bodyPr wrap="square">
-            <a:spAutoFit/>
-          </a:bodyPr>
-          <a:lstStyle/>
-          <a:p>
-            <a:pPr>
-              <a:defRPr sz="1050" b="1">
-                <a:solidFill>
-                  <a:srgbClr val="B48214"/>
-                </a:solidFill>
-              </a:defRPr>
-            </a:pPr>
-            <a:r>
-              <a:t>SUBSIDIARY CFOS (OPERATING UNITS)</a:t>
-            </a:r>
-          </a:p>
-          <a:p>
-            <a:pPr>
-              <a:defRPr sz="1050">
+              <a:t>Total RP Receivables: $241M</a:t>
+            </a:r>
+            <a:br/>
+            <a:r>
+              <a:t>Share of Total Assets: 4.3%</a:t>
+            </a:r>
+          </a:p>
+          <a:p>
+            <a:pPr>
+              <a:spcAft>
+                <a:spcPts val="1000"/>
+              </a:spcAft>
+              <a:defRPr sz="1000" b="1">
+                <a:solidFill>
+                  <a:srgbClr val="D97706"/>
+                </a:solidFill>
+              </a:defRPr>
+            </a:pPr>
+            <a:r>
+              <a:t>STATUS: CONCENTRATION WATCH</a:t>
+            </a:r>
+          </a:p>
+          <a:p>
+            <a:pPr>
+              <a:spcAft>
+                <a:spcPts val="400"/>
+              </a:spcAft>
+              <a:defRPr sz="1100">
                 <a:solidFill>
                   <a:srgbClr val="1E293B"/>
                 </a:solidFill>
               </a:defRPr>
             </a:pPr>
             <a:r>
-              <a:t>Expectation: "Ensure transparent, fair elimination and reconciliation calculations."  ➔  Delivery: Line-by-line breakdown of all variances enables rapid cross-checking against subsidiary general ledgers.</a:t>
-            </a:r>
-          </a:p>
-        </p:txBody>
-      </p:sp>
-      <p:sp>
-        <p:nvSpPr>
-          <p:cNvPr id="18" name="Rounded Rectangle 17"/>
-          <p:cNvSpPr/>
-          <p:nvPr/>
-        </p:nvSpPr>
-        <p:spPr>
-          <a:xfrm>
-            <a:off x="731520" y="5212080"/>
-            <a:ext cx="10728655" cy="822960"/>
-          </a:xfrm>
-          <a:prstGeom prst="roundRect">
-            <a:avLst/>
-          </a:prstGeom>
-          <a:solidFill>
-            <a:srgbClr val="F8FAFC"/>
-          </a:solidFill>
-          <a:ln>
-            <a:solidFill>
-              <a:srgbClr val="E2E8F0"/>
-            </a:solidFill>
-          </a:ln>
-        </p:spPr>
-        <p:style>
-          <a:lnRef idx="1">
-            <a:schemeClr val="accent1"/>
-          </a:lnRef>
-          <a:fillRef idx="3">
-            <a:schemeClr val="accent1"/>
-          </a:fillRef>
-          <a:effectRef idx="2">
-            <a:schemeClr val="accent1"/>
-          </a:effectRef>
-          <a:fontRef idx="minor">
-            <a:schemeClr val="lt1"/>
-          </a:fontRef>
-        </p:style>
-        <p:txBody>
-          <a:bodyPr rtlCol="0" anchor="ctr"/>
-          <a:lstStyle/>
-          <a:p>
-            <a:pPr algn="ctr"/>
-          </a:p>
-        </p:txBody>
-      </p:sp>
-      <p:sp>
-        <p:nvSpPr>
-          <p:cNvPr id="19" name="Rectangle 18"/>
-          <p:cNvSpPr/>
-          <p:nvPr/>
-        </p:nvSpPr>
-        <p:spPr>
-          <a:xfrm>
-            <a:off x="731520" y="5212080"/>
-            <a:ext cx="54864" cy="822960"/>
-          </a:xfrm>
-          <a:prstGeom prst="rect">
-            <a:avLst/>
-          </a:prstGeom>
-          <a:solidFill>
-            <a:srgbClr val="1B4332"/>
-          </a:solidFill>
-          <a:ln>
-            <a:noFill/>
-          </a:ln>
-        </p:spPr>
-        <p:style>
-          <a:lnRef idx="1">
-            <a:schemeClr val="accent1"/>
-          </a:lnRef>
-          <a:fillRef idx="3">
-            <a:schemeClr val="accent1"/>
-          </a:fillRef>
-          <a:effectRef idx="2">
-            <a:schemeClr val="accent1"/>
-          </a:effectRef>
-          <a:fontRef idx="minor">
-            <a:schemeClr val="lt1"/>
-          </a:fontRef>
-        </p:style>
-        <p:txBody>
-          <a:bodyPr rtlCol="0" anchor="ctr"/>
-          <a:lstStyle/>
-          <a:p>
-            <a:pPr algn="ctr"/>
-          </a:p>
-        </p:txBody>
-      </p:sp>
-      <p:sp>
-        <p:nvSpPr>
-          <p:cNvPr id="20" name="TextBox 19"/>
-          <p:cNvSpPr txBox="1"/>
-          <p:nvPr/>
-        </p:nvSpPr>
-        <p:spPr>
-          <a:xfrm>
-            <a:off x="914400" y="5285232"/>
-            <a:ext cx="10332720" cy="685800"/>
-          </a:xfrm>
-          <a:prstGeom prst="rect">
-            <a:avLst/>
-          </a:prstGeom>
-          <a:noFill/>
-        </p:spPr>
-        <p:txBody>
-          <a:bodyPr wrap="square">
-            <a:spAutoFit/>
-          </a:bodyPr>
-          <a:lstStyle/>
-          <a:p>
-            <a:pPr>
-              <a:defRPr sz="1050" b="1">
-                <a:solidFill>
-                  <a:srgbClr val="B48214"/>
-                </a:solidFill>
-              </a:defRPr>
-            </a:pPr>
-            <a:r>
-              <a:t>IT &amp; DATA GOVERNANCE</a:t>
-            </a:r>
-          </a:p>
-          <a:p>
-            <a:pPr>
-              <a:defRPr sz="1050">
+              <a:t>• Aggregate exposure is proportional to balance sheet scale.</a:t>
+            </a:r>
+          </a:p>
+          <a:p>
+            <a:pPr>
+              <a:spcAft>
+                <a:spcPts val="400"/>
+              </a:spcAft>
+              <a:defRPr sz="1100">
                 <a:solidFill>
                   <a:srgbClr val="1E293B"/>
                 </a:solidFill>
               </a:defRPr>
             </a:pPr>
             <a:r>
-              <a:t>Expectation: "Strict data privacy with no exposure of unreleased financials to public LLMs."  ➔  Delivery: Runs entirely client-side/on-premise; append-only point-in-time snapshot persistence.</a:t>
+              <a:t>• However, concentration at Subsidiary II ($88M) warrants tight monitoring.</a:t>
             </a:r>
           </a:p>
         </p:txBody>
@@ -9663,7 +10622,7 @@
               </a:defRPr>
             </a:pPr>
             <a:r>
-              <a:t>DEPLOYMENT PLAN</a:t>
+              <a:t>VALUE DELIVERY</a:t>
             </a:r>
           </a:p>
         </p:txBody>
@@ -9698,7 +10657,7 @@
               </a:defRPr>
             </a:pPr>
             <a:r>
-              <a:t>Phased Enterprise Implementation Roadmap</a:t>
+              <a:t>Stakeholder Expectation Alignment Matrix</a:t>
             </a:r>
           </a:p>
         </p:txBody>
@@ -9711,8 +10670,8 @@
         </p:nvSpPr>
         <p:spPr>
           <a:xfrm>
-            <a:off x="731520" y="1600200"/>
-            <a:ext cx="3328416" cy="4389120"/>
+            <a:off x="731520" y="1554480"/>
+            <a:ext cx="10728655" cy="822960"/>
           </a:xfrm>
           <a:prstGeom prst="roundRect">
             <a:avLst/>
@@ -9720,7 +10679,7 @@
           <a:solidFill>
             <a:srgbClr val="F8FAFC"/>
           </a:solidFill>
-          <a:ln w="12700">
+          <a:ln>
             <a:solidFill>
               <a:srgbClr val="E2E8F0"/>
             </a:solidFill>
@@ -9750,20 +10709,20 @@
       </p:sp>
       <p:sp>
         <p:nvSpPr>
-          <p:cNvPr id="7" name="Rounded Rectangle 6"/>
+          <p:cNvPr id="7" name="Rectangle 6"/>
           <p:cNvSpPr/>
           <p:nvPr/>
         </p:nvSpPr>
         <p:spPr>
           <a:xfrm>
-            <a:off x="731520" y="1600200"/>
-            <a:ext cx="3328416" cy="73152"/>
-          </a:xfrm>
-          <a:prstGeom prst="roundRect">
-            <a:avLst/>
-          </a:prstGeom>
-          <a:solidFill>
-            <a:srgbClr val="0D9488"/>
+            <a:off x="731520" y="1554480"/>
+            <a:ext cx="54864" cy="822960"/>
+          </a:xfrm>
+          <a:prstGeom prst="rect">
+            <a:avLst/>
+          </a:prstGeom>
+          <a:solidFill>
+            <a:srgbClr val="1B4332"/>
           </a:solidFill>
           <a:ln>
             <a:noFill/>
@@ -9799,8 +10758,8 @@
         </p:nvSpPr>
         <p:spPr>
           <a:xfrm>
-            <a:off x="950976" y="1819656"/>
-            <a:ext cx="2889504" cy="3950208"/>
+            <a:off x="914400" y="1627632"/>
+            <a:ext cx="10332720" cy="685800"/>
           </a:xfrm>
           <a:prstGeom prst="rect">
             <a:avLst/>
@@ -9814,81 +10773,26 @@
           <a:lstStyle/>
           <a:p>
             <a:pPr>
-              <a:spcAft>
-                <a:spcPts val="800"/>
-              </a:spcAft>
-              <a:defRPr sz="1350" b="1">
-                <a:solidFill>
-                  <a:srgbClr val="0D9488"/>
-                </a:solidFill>
-              </a:defRPr>
-            </a:pPr>
-            <a:r>
-              <a:t>Phase 1: Working PoC (Delivered)</a:t>
-            </a:r>
-            <a:br/>
-            <a:r>
-              <a:t>(Month 1)</a:t>
-            </a:r>
-          </a:p>
-          <a:p>
-            <a:pPr>
-              <a:spcAft>
-                <a:spcPts val="400"/>
-              </a:spcAft>
-              <a:defRPr sz="1100">
+              <a:defRPr sz="1050" b="1">
+                <a:solidFill>
+                  <a:srgbClr val="B48214"/>
+                </a:solidFill>
+              </a:defRPr>
+            </a:pPr>
+            <a:r>
+              <a:t>AUDIT COMMITTEE / BOARD OF SUPERVISORS</a:t>
+            </a:r>
+          </a:p>
+          <a:p>
+            <a:pPr>
+              <a:defRPr sz="1050">
                 <a:solidFill>
                   <a:srgbClr val="1E293B"/>
                 </a:solidFill>
               </a:defRPr>
             </a:pPr>
             <a:r>
-              <a:t>• Consolidation rule engine validated for 6 entities.</a:t>
-            </a:r>
-          </a:p>
-          <a:p>
-            <a:pPr>
-              <a:spcAft>
-                <a:spcPts val="400"/>
-              </a:spcAft>
-              <a:defRPr sz="1100">
-                <a:solidFill>
-                  <a:srgbClr val="1E293B"/>
-                </a:solidFill>
-              </a:defRPr>
-            </a:pPr>
-            <a:r>
-              <a:t>• Conversational AI Copilot with quick-action chips.</a:t>
-            </a:r>
-          </a:p>
-          <a:p>
-            <a:pPr>
-              <a:spcAft>
-                <a:spcPts val="400"/>
-              </a:spcAft>
-              <a:defRPr sz="1100">
-                <a:solidFill>
-                  <a:srgbClr val="1E293B"/>
-                </a:solidFill>
-              </a:defRPr>
-            </a:pPr>
-            <a:r>
-              <a:t>• Actionable 'Review Workspace' for anomaly tracking.</a:t>
-            </a:r>
-          </a:p>
-          <a:p>
-            <a:pPr>
-              <a:spcAft>
-                <a:spcPts val="400"/>
-              </a:spcAft>
-              <a:defRPr sz="1100">
-                <a:solidFill>
-                  <a:srgbClr val="1E293B"/>
-                </a:solidFill>
-              </a:defRPr>
-            </a:pPr>
-            <a:r>
-              <a:t>• Self-contained local execution &amp; GitHub repository.</a:t>
+              <a:t>Expectation: "Prevent material misstatements &amp; NCI leakage prior to external audits."  ➔  Delivery: Automated IFRS 10 rule engine verifies profit distribution &amp; flags critical anomalies instantly.</a:t>
             </a:r>
           </a:p>
         </p:txBody>
@@ -9901,8 +10805,8 @@
         </p:nvSpPr>
         <p:spPr>
           <a:xfrm>
-            <a:off x="4416552" y="1600200"/>
-            <a:ext cx="3328416" cy="4389120"/>
+            <a:off x="731520" y="2468880"/>
+            <a:ext cx="10728655" cy="822960"/>
           </a:xfrm>
           <a:prstGeom prst="roundRect">
             <a:avLst/>
@@ -9910,7 +10814,7 @@
           <a:solidFill>
             <a:srgbClr val="F8FAFC"/>
           </a:solidFill>
-          <a:ln w="12700">
+          <a:ln>
             <a:solidFill>
               <a:srgbClr val="E2E8F0"/>
             </a:solidFill>
@@ -9940,20 +10844,20 @@
       </p:sp>
       <p:sp>
         <p:nvSpPr>
-          <p:cNvPr id="10" name="Rounded Rectangle 9"/>
+          <p:cNvPr id="10" name="Rectangle 9"/>
           <p:cNvSpPr/>
           <p:nvPr/>
         </p:nvSpPr>
         <p:spPr>
           <a:xfrm>
-            <a:off x="4416552" y="1600200"/>
-            <a:ext cx="3328416" cy="73152"/>
-          </a:xfrm>
-          <a:prstGeom prst="roundRect">
-            <a:avLst/>
-          </a:prstGeom>
-          <a:solidFill>
-            <a:srgbClr val="B48214"/>
+            <a:off x="731520" y="2468880"/>
+            <a:ext cx="54864" cy="822960"/>
+          </a:xfrm>
+          <a:prstGeom prst="rect">
+            <a:avLst/>
+          </a:prstGeom>
+          <a:solidFill>
+            <a:srgbClr val="1B4332"/>
           </a:solidFill>
           <a:ln>
             <a:noFill/>
@@ -9989,8 +10893,8 @@
         </p:nvSpPr>
         <p:spPr>
           <a:xfrm>
-            <a:off x="4636008" y="1819656"/>
-            <a:ext cx="2889504" cy="3950208"/>
+            <a:off x="914400" y="2542032"/>
+            <a:ext cx="10332720" cy="685800"/>
           </a:xfrm>
           <a:prstGeom prst="rect">
             <a:avLst/>
@@ -10004,81 +10908,26 @@
           <a:lstStyle/>
           <a:p>
             <a:pPr>
-              <a:spcAft>
-                <a:spcPts val="800"/>
-              </a:spcAft>
-              <a:defRPr sz="1350" b="1">
+              <a:defRPr sz="1050" b="1">
                 <a:solidFill>
                   <a:srgbClr val="B48214"/>
                 </a:solidFill>
               </a:defRPr>
             </a:pPr>
             <a:r>
-              <a:t>Phase 2: Integration &amp; Pilot</a:t>
-            </a:r>
-            <a:br/>
-            <a:r>
-              <a:t>(Months 2 - 3)</a:t>
-            </a:r>
-          </a:p>
-          <a:p>
-            <a:pPr>
-              <a:spcAft>
-                <a:spcPts val="400"/>
-              </a:spcAft>
-              <a:defRPr sz="1100">
+              <a:t>GROUP CHIEF FINANCIAL OFFICER (CFO)</a:t>
+            </a:r>
+          </a:p>
+          <a:p>
+            <a:pPr>
+              <a:defRPr sz="1050">
                 <a:solidFill>
                   <a:srgbClr val="1E293B"/>
                 </a:solidFill>
               </a:defRPr>
             </a:pPr>
             <a:r>
-              <a:t>• Direct ERP/GL database connectors (SAP/Oracle).</a:t>
-            </a:r>
-          </a:p>
-          <a:p>
-            <a:pPr>
-              <a:spcAft>
-                <a:spcPts val="400"/>
-              </a:spcAft>
-              <a:defRPr sz="1100">
-                <a:solidFill>
-                  <a:srgbClr val="1E293B"/>
-                </a:solidFill>
-              </a:defRPr>
-            </a:pPr>
-            <a:r>
-              <a:t>• Immutable point-in-time snapshot database store.</a:t>
-            </a:r>
-          </a:p>
-          <a:p>
-            <a:pPr>
-              <a:spcAft>
-                <a:spcPts val="400"/>
-              </a:spcAft>
-              <a:defRPr sz="1100">
-                <a:solidFill>
-                  <a:srgbClr val="1E293B"/>
-                </a:solidFill>
-              </a:defRPr>
-            </a:pPr>
-            <a:r>
-              <a:t>• Automated email/chat notification dispatch to subsidiaries.</a:t>
-            </a:r>
-          </a:p>
-          <a:p>
-            <a:pPr>
-              <a:spcAft>
-                <a:spcPts val="400"/>
-              </a:spcAft>
-              <a:defRPr sz="1100">
-                <a:solidFill>
-                  <a:srgbClr val="1E293B"/>
-                </a:solidFill>
-              </a:defRPr>
-            </a:pPr>
-            <a:r>
-              <a:t>• Parallel dry-run benchmarked against prior-year audited data.</a:t>
+              <a:t>Expectation: "Accelerate group consolidation closing cycles with zero arithmetic risk."  ➔  Delivery: Dynamic KPI summaries, instant sensitivity simulations, and executive board-ready memos.</a:t>
             </a:r>
           </a:p>
         </p:txBody>
@@ -10091,8 +10940,8 @@
         </p:nvSpPr>
         <p:spPr>
           <a:xfrm>
-            <a:off x="8101584" y="1600200"/>
-            <a:ext cx="3328416" cy="4389120"/>
+            <a:off x="731520" y="3383280"/>
+            <a:ext cx="10728655" cy="822960"/>
           </a:xfrm>
           <a:prstGeom prst="roundRect">
             <a:avLst/>
@@ -10100,7 +10949,7 @@
           <a:solidFill>
             <a:srgbClr val="F8FAFC"/>
           </a:solidFill>
-          <a:ln w="12700">
+          <a:ln>
             <a:solidFill>
               <a:srgbClr val="E2E8F0"/>
             </a:solidFill>
@@ -10130,16 +10979,16 @@
       </p:sp>
       <p:sp>
         <p:nvSpPr>
-          <p:cNvPr id="13" name="Rounded Rectangle 12"/>
+          <p:cNvPr id="13" name="Rectangle 12"/>
           <p:cNvSpPr/>
           <p:nvPr/>
         </p:nvSpPr>
         <p:spPr>
           <a:xfrm>
-            <a:off x="8101584" y="1600200"/>
-            <a:ext cx="3328416" cy="73152"/>
-          </a:xfrm>
-          <a:prstGeom prst="roundRect">
+            <a:off x="731520" y="3383280"/>
+            <a:ext cx="54864" cy="822960"/>
+          </a:xfrm>
+          <a:prstGeom prst="rect">
             <a:avLst/>
           </a:prstGeom>
           <a:solidFill>
@@ -10179,8 +11028,8 @@
         </p:nvSpPr>
         <p:spPr>
           <a:xfrm>
-            <a:off x="8321040" y="1819656"/>
-            <a:ext cx="2889504" cy="3950208"/>
+            <a:off x="914400" y="3456432"/>
+            <a:ext cx="10332720" cy="685800"/>
           </a:xfrm>
           <a:prstGeom prst="rect">
             <a:avLst/>
@@ -10194,81 +11043,296 @@
           <a:lstStyle/>
           <a:p>
             <a:pPr>
-              <a:spcAft>
-                <a:spcPts val="800"/>
-              </a:spcAft>
-              <a:defRPr sz="1350" b="1">
-                <a:solidFill>
-                  <a:srgbClr val="1B4332"/>
-                </a:solidFill>
-              </a:defRPr>
-            </a:pPr>
-            <a:r>
-              <a:t>Phase 3: Full Enterprise Rollout</a:t>
-            </a:r>
-            <a:br/>
-            <a:r>
-              <a:t>(Month 4+)</a:t>
-            </a:r>
-          </a:p>
-          <a:p>
-            <a:pPr>
-              <a:spcAft>
-                <a:spcPts val="400"/>
-              </a:spcAft>
-              <a:defRPr sz="1100">
+              <a:defRPr sz="1050" b="1">
+                <a:solidFill>
+                  <a:srgbClr val="B48214"/>
+                </a:solidFill>
+              </a:defRPr>
+            </a:pPr>
+            <a:r>
+              <a:t>INTERNAL AUDIT LEADERSHIP</a:t>
+            </a:r>
+          </a:p>
+          <a:p>
+            <a:pPr>
+              <a:defRPr sz="1050">
                 <a:solidFill>
                   <a:srgbClr val="1E293B"/>
                 </a:solidFill>
               </a:defRPr>
             </a:pPr>
             <a:r>
-              <a:t>• Multi-tenant Role-Based Access Control (RBAC) &amp; SSO.</a:t>
-            </a:r>
-          </a:p>
-          <a:p>
-            <a:pPr>
-              <a:spcAft>
-                <a:spcPts val="400"/>
-              </a:spcAft>
-              <a:defRPr sz="1100">
+              <a:t>Expectation: "Maintain structured electronic workpapers with traceable sign-offs."  ➔  Delivery: Actionable Review Workspace with item status toggles, auditor notes, and timestamped audit trails.</a:t>
+            </a:r>
+          </a:p>
+        </p:txBody>
+      </p:sp>
+      <p:sp>
+        <p:nvSpPr>
+          <p:cNvPr id="15" name="Rounded Rectangle 14"/>
+          <p:cNvSpPr/>
+          <p:nvPr/>
+        </p:nvSpPr>
+        <p:spPr>
+          <a:xfrm>
+            <a:off x="731520" y="4297680"/>
+            <a:ext cx="10728655" cy="822960"/>
+          </a:xfrm>
+          <a:prstGeom prst="roundRect">
+            <a:avLst/>
+          </a:prstGeom>
+          <a:solidFill>
+            <a:srgbClr val="F8FAFC"/>
+          </a:solidFill>
+          <a:ln>
+            <a:solidFill>
+              <a:srgbClr val="E2E8F0"/>
+            </a:solidFill>
+          </a:ln>
+        </p:spPr>
+        <p:style>
+          <a:lnRef idx="1">
+            <a:schemeClr val="accent1"/>
+          </a:lnRef>
+          <a:fillRef idx="3">
+            <a:schemeClr val="accent1"/>
+          </a:fillRef>
+          <a:effectRef idx="2">
+            <a:schemeClr val="accent1"/>
+          </a:effectRef>
+          <a:fontRef idx="minor">
+            <a:schemeClr val="lt1"/>
+          </a:fontRef>
+        </p:style>
+        <p:txBody>
+          <a:bodyPr rtlCol="0" anchor="ctr"/>
+          <a:lstStyle/>
+          <a:p>
+            <a:pPr algn="ctr"/>
+          </a:p>
+        </p:txBody>
+      </p:sp>
+      <p:sp>
+        <p:nvSpPr>
+          <p:cNvPr id="16" name="Rectangle 15"/>
+          <p:cNvSpPr/>
+          <p:nvPr/>
+        </p:nvSpPr>
+        <p:spPr>
+          <a:xfrm>
+            <a:off x="731520" y="4297680"/>
+            <a:ext cx="54864" cy="822960"/>
+          </a:xfrm>
+          <a:prstGeom prst="rect">
+            <a:avLst/>
+          </a:prstGeom>
+          <a:solidFill>
+            <a:srgbClr val="1B4332"/>
+          </a:solidFill>
+          <a:ln>
+            <a:noFill/>
+          </a:ln>
+        </p:spPr>
+        <p:style>
+          <a:lnRef idx="1">
+            <a:schemeClr val="accent1"/>
+          </a:lnRef>
+          <a:fillRef idx="3">
+            <a:schemeClr val="accent1"/>
+          </a:fillRef>
+          <a:effectRef idx="2">
+            <a:schemeClr val="accent1"/>
+          </a:effectRef>
+          <a:fontRef idx="minor">
+            <a:schemeClr val="lt1"/>
+          </a:fontRef>
+        </p:style>
+        <p:txBody>
+          <a:bodyPr rtlCol="0" anchor="ctr"/>
+          <a:lstStyle/>
+          <a:p>
+            <a:pPr algn="ctr"/>
+          </a:p>
+        </p:txBody>
+      </p:sp>
+      <p:sp>
+        <p:nvSpPr>
+          <p:cNvPr id="17" name="TextBox 16"/>
+          <p:cNvSpPr txBox="1"/>
+          <p:nvPr/>
+        </p:nvSpPr>
+        <p:spPr>
+          <a:xfrm>
+            <a:off x="914400" y="4370832"/>
+            <a:ext cx="10332720" cy="685800"/>
+          </a:xfrm>
+          <a:prstGeom prst="rect">
+            <a:avLst/>
+          </a:prstGeom>
+          <a:noFill/>
+        </p:spPr>
+        <p:txBody>
+          <a:bodyPr wrap="square">
+            <a:spAutoFit/>
+          </a:bodyPr>
+          <a:lstStyle/>
+          <a:p>
+            <a:pPr>
+              <a:defRPr sz="1050" b="1">
+                <a:solidFill>
+                  <a:srgbClr val="B48214"/>
+                </a:solidFill>
+              </a:defRPr>
+            </a:pPr>
+            <a:r>
+              <a:t>SUBSIDIARY CFOS (OPERATING UNITS)</a:t>
+            </a:r>
+          </a:p>
+          <a:p>
+            <a:pPr>
+              <a:defRPr sz="1050">
                 <a:solidFill>
                   <a:srgbClr val="1E293B"/>
                 </a:solidFill>
               </a:defRPr>
             </a:pPr>
             <a:r>
-              <a:t>• Transaction-level automated intercompany elimination.</a:t>
-            </a:r>
-          </a:p>
-          <a:p>
-            <a:pPr>
-              <a:spcAft>
-                <a:spcPts val="400"/>
-              </a:spcAft>
-              <a:defRPr sz="1100">
+              <a:t>Expectation: "Ensure transparent, fair elimination and reconciliation calculations."  ➔  Delivery: Line-by-line breakdown of all variances enables rapid cross-checking against subsidiary general ledgers.</a:t>
+            </a:r>
+          </a:p>
+        </p:txBody>
+      </p:sp>
+      <p:sp>
+        <p:nvSpPr>
+          <p:cNvPr id="18" name="Rounded Rectangle 17"/>
+          <p:cNvSpPr/>
+          <p:nvPr/>
+        </p:nvSpPr>
+        <p:spPr>
+          <a:xfrm>
+            <a:off x="731520" y="5212080"/>
+            <a:ext cx="10728655" cy="822960"/>
+          </a:xfrm>
+          <a:prstGeom prst="roundRect">
+            <a:avLst/>
+          </a:prstGeom>
+          <a:solidFill>
+            <a:srgbClr val="F8FAFC"/>
+          </a:solidFill>
+          <a:ln>
+            <a:solidFill>
+              <a:srgbClr val="E2E8F0"/>
+            </a:solidFill>
+          </a:ln>
+        </p:spPr>
+        <p:style>
+          <a:lnRef idx="1">
+            <a:schemeClr val="accent1"/>
+          </a:lnRef>
+          <a:fillRef idx="3">
+            <a:schemeClr val="accent1"/>
+          </a:fillRef>
+          <a:effectRef idx="2">
+            <a:schemeClr val="accent1"/>
+          </a:effectRef>
+          <a:fontRef idx="minor">
+            <a:schemeClr val="lt1"/>
+          </a:fontRef>
+        </p:style>
+        <p:txBody>
+          <a:bodyPr rtlCol="0" anchor="ctr"/>
+          <a:lstStyle/>
+          <a:p>
+            <a:pPr algn="ctr"/>
+          </a:p>
+        </p:txBody>
+      </p:sp>
+      <p:sp>
+        <p:nvSpPr>
+          <p:cNvPr id="19" name="Rectangle 18"/>
+          <p:cNvSpPr/>
+          <p:nvPr/>
+        </p:nvSpPr>
+        <p:spPr>
+          <a:xfrm>
+            <a:off x="731520" y="5212080"/>
+            <a:ext cx="54864" cy="822960"/>
+          </a:xfrm>
+          <a:prstGeom prst="rect">
+            <a:avLst/>
+          </a:prstGeom>
+          <a:solidFill>
+            <a:srgbClr val="1B4332"/>
+          </a:solidFill>
+          <a:ln>
+            <a:noFill/>
+          </a:ln>
+        </p:spPr>
+        <p:style>
+          <a:lnRef idx="1">
+            <a:schemeClr val="accent1"/>
+          </a:lnRef>
+          <a:fillRef idx="3">
+            <a:schemeClr val="accent1"/>
+          </a:fillRef>
+          <a:effectRef idx="2">
+            <a:schemeClr val="accent1"/>
+          </a:effectRef>
+          <a:fontRef idx="minor">
+            <a:schemeClr val="lt1"/>
+          </a:fontRef>
+        </p:style>
+        <p:txBody>
+          <a:bodyPr rtlCol="0" anchor="ctr"/>
+          <a:lstStyle/>
+          <a:p>
+            <a:pPr algn="ctr"/>
+          </a:p>
+        </p:txBody>
+      </p:sp>
+      <p:sp>
+        <p:nvSpPr>
+          <p:cNvPr id="20" name="TextBox 19"/>
+          <p:cNvSpPr txBox="1"/>
+          <p:nvPr/>
+        </p:nvSpPr>
+        <p:spPr>
+          <a:xfrm>
+            <a:off x="914400" y="5285232"/>
+            <a:ext cx="10332720" cy="685800"/>
+          </a:xfrm>
+          <a:prstGeom prst="rect">
+            <a:avLst/>
+          </a:prstGeom>
+          <a:noFill/>
+        </p:spPr>
+        <p:txBody>
+          <a:bodyPr wrap="square">
+            <a:spAutoFit/>
+          </a:bodyPr>
+          <a:lstStyle/>
+          <a:p>
+            <a:pPr>
+              <a:defRPr sz="1050" b="1">
+                <a:solidFill>
+                  <a:srgbClr val="B48214"/>
+                </a:solidFill>
+              </a:defRPr>
+            </a:pPr>
+            <a:r>
+              <a:t>IT &amp; DATA GOVERNANCE</a:t>
+            </a:r>
+          </a:p>
+          <a:p>
+            <a:pPr>
+              <a:defRPr sz="1050">
                 <a:solidFill>
                   <a:srgbClr val="1E293B"/>
                 </a:solidFill>
               </a:defRPr>
             </a:pPr>
             <a:r>
-              <a:t>• Dedicated secure portal for external audit review teams.</a:t>
-            </a:r>
-          </a:p>
-          <a:p>
-            <a:pPr>
-              <a:spcAft>
-                <a:spcPts val="400"/>
-              </a:spcAft>
-              <a:defRPr sz="1100">
-                <a:solidFill>
-                  <a:srgbClr val="1E293B"/>
-                </a:solidFill>
-              </a:defRPr>
-            </a:pPr>
-            <a:r>
-              <a:t>• Continuous group-wide financial health telemetry.</a:t>
+              <a:t>Expectation: "Strict data privacy with no exposure of unreleased financials to public LLMs."  ➔  Delivery: Runs entirely client-side/on-premise; append-only point-in-time snapshot persistence.</a:t>
             </a:r>
           </a:p>
         </p:txBody>

</xml_diff>